<commit_message>
Añadir respuestas al debate/repaso en Módulos 3 y 4, reorganizar previews y archivos
Módulo 3:
- Añadir respuestas al final de días 1-5 (sin tocar slides existentes)
- Añadir respuestas a adopcion.pptx (movido de Módulo 4 a Módulo 3)
- Añadir respuestas a los 5 previews (preview01-05)
- Renombrar preview_b3i y preview_tradelens a preview04/05 para orden coherente
- Añadir Modulo_3.pptx consolidado

Módulo 4:
- Añadir respuestas al final de dia1_anexo.pptx y día_1.pptx
- Añadir Modulo_4.pptx consolidado
- Eliminar archivos temporales (copias de dia_2/dia_3, PDF día 1)

Scripts auxiliares:
- add_respuestas_*.py: añaden slides sin regenerar archivos
- crear_mix_m3.py: combinar adopcion + dia_1 en un mix
- Scripts de inspección (ver_*) para no tocar archivos binarios

Co-Authored-By: Claude Opus 4.6 (1M context) <noreply@anthropic.com>
</commit_message>
<xml_diff>
--- a/docs/slides/Modulo 3/dia_1.pptx
+++ b/docs/slides/Modulo 3/dia_1.pptx
@@ -5,24 +5,27 @@
     <p:sldMasterId id="2147483648" r:id="rId1"/>
   </p:sldMasterIdLst>
   <p:sldIdLst>
-    <p:sldId id="256" r:id="rId7"/>
-    <p:sldId id="257" r:id="rId8"/>
-    <p:sldId id="258" r:id="rId9"/>
-    <p:sldId id="259" r:id="rId10"/>
-    <p:sldId id="260" r:id="rId11"/>
-    <p:sldId id="261" r:id="rId12"/>
-    <p:sldId id="262" r:id="rId13"/>
-    <p:sldId id="263" r:id="rId14"/>
-    <p:sldId id="264" r:id="rId15"/>
-    <p:sldId id="265" r:id="rId16"/>
-    <p:sldId id="266" r:id="rId17"/>
-    <p:sldId id="267" r:id="rId18"/>
-    <p:sldId id="268" r:id="rId19"/>
-    <p:sldId id="269" r:id="rId20"/>
-    <p:sldId id="270" r:id="rId21"/>
-    <p:sldId id="271" r:id="rId22"/>
+    <p:sldId id="256" r:id="rId2"/>
+    <p:sldId id="257" r:id="rId3"/>
+    <p:sldId id="258" r:id="rId4"/>
+    <p:sldId id="259" r:id="rId5"/>
+    <p:sldId id="260" r:id="rId6"/>
+    <p:sldId id="261" r:id="rId7"/>
+    <p:sldId id="262" r:id="rId8"/>
+    <p:sldId id="263" r:id="rId9"/>
+    <p:sldId id="264" r:id="rId10"/>
+    <p:sldId id="265" r:id="rId11"/>
+    <p:sldId id="266" r:id="rId12"/>
+    <p:sldId id="267" r:id="rId13"/>
+    <p:sldId id="268" r:id="rId14"/>
+    <p:sldId id="270" r:id="rId15"/>
+    <p:sldId id="269" r:id="rId16"/>
+    <p:sldId id="271" r:id="rId17"/>
+    <p:sldId id="272" r:id="rId18"/>
+    <p:sldId id="273" r:id="rId19"/>
+    <p:sldId id="274" r:id="rId20"/>
   </p:sldIdLst>
-  <p:sldSz cx="12188952" cy="6858000" type="screen4x3"/>
+  <p:sldSz cx="12188825" cy="6858000"/>
   <p:notesSz cx="6858000" cy="9144000"/>
   <p:defaultTextStyle>
     <a:defPPr>
@@ -119,6 +122,22 @@
       </a:defRPr>
     </a:lvl9pPr>
   </p:defaultTextStyle>
+  <p:extLst>
+    <p:ext uri="{EFAFB233-063F-42B5-8137-9DF3F51BA10A}">
+      <p15:sldGuideLst xmlns:p15="http://schemas.microsoft.com/office/powerpoint/2012/main">
+        <p15:guide id="1" orient="horz" pos="2160">
+          <p15:clr>
+            <a:srgbClr val="A4A3A4"/>
+          </p15:clr>
+        </p15:guide>
+        <p15:guide id="2" pos="2880">
+          <p15:clr>
+            <a:srgbClr val="A4A3A4"/>
+          </p15:clr>
+        </p15:guide>
+      </p15:sldGuideLst>
+    </p:ext>
+  </p:extLst>
 </p:presentation>
 </file>
 
@@ -160,10 +179,9 @@
           <a:lstStyle/>
           <a:p>
             <a:r>
-              <a:rPr lang="en-US" smtClean="0"/>
+              <a:rPr lang="en-US"/>
               <a:t>Click to edit Master title style</a:t>
             </a:r>
-            <a:endParaRPr lang="en-US"/>
           </a:p>
         </p:txBody>
       </p:sp>
@@ -279,10 +297,9 @@
           </a:lstStyle>
           <a:p>
             <a:r>
-              <a:rPr lang="en-US" smtClean="0"/>
+              <a:rPr lang="en-US"/>
               <a:t>Click to edit Master subtitle style</a:t>
             </a:r>
-            <a:endParaRPr lang="en-US"/>
           </a:p>
         </p:txBody>
       </p:sp>
@@ -303,7 +320,7 @@
           <a:p>
             <a:fld id="{5BCAD085-E8A6-8845-BD4E-CB4CCA059FC4}" type="datetimeFigureOut">
               <a:rPr lang="en-US" smtClean="0"/>
-              <a:t>1/27/13</a:t>
+              <a:t>4/23/2026</a:t>
             </a:fld>
             <a:endParaRPr lang="en-US"/>
           </a:p>
@@ -345,7 +362,7 @@
           <a:p>
             <a:fld id="{C1FF6DA9-008F-8B48-92A6-B652298478BF}" type="slidenum">
               <a:rPr lang="en-US" smtClean="0"/>
-              <a:t>‹#›</a:t>
+              <a:t>‹Nº›</a:t>
             </a:fld>
             <a:endParaRPr lang="en-US"/>
           </a:p>
@@ -397,10 +414,9 @@
           <a:lstStyle/>
           <a:p>
             <a:r>
-              <a:rPr lang="en-US" smtClean="0"/>
+              <a:rPr lang="en-US"/>
               <a:t>Click to edit Master title style</a:t>
             </a:r>
-            <a:endParaRPr lang="en-US"/>
           </a:p>
         </p:txBody>
       </p:sp>
@@ -421,38 +437,37 @@
           <a:p>
             <a:pPr lvl="0"/>
             <a:r>
-              <a:rPr lang="en-US" smtClean="0"/>
+              <a:rPr lang="en-US"/>
               <a:t>Click to edit Master text styles</a:t>
             </a:r>
           </a:p>
           <a:p>
             <a:pPr lvl="1"/>
             <a:r>
-              <a:rPr lang="en-US" smtClean="0"/>
+              <a:rPr lang="en-US"/>
               <a:t>Second level</a:t>
             </a:r>
           </a:p>
           <a:p>
             <a:pPr lvl="2"/>
             <a:r>
-              <a:rPr lang="en-US" smtClean="0"/>
+              <a:rPr lang="en-US"/>
               <a:t>Third level</a:t>
             </a:r>
           </a:p>
           <a:p>
             <a:pPr lvl="3"/>
             <a:r>
-              <a:rPr lang="en-US" smtClean="0"/>
+              <a:rPr lang="en-US"/>
               <a:t>Fourth level</a:t>
             </a:r>
           </a:p>
           <a:p>
             <a:pPr lvl="4"/>
             <a:r>
-              <a:rPr lang="en-US" smtClean="0"/>
+              <a:rPr lang="en-US"/>
               <a:t>Fifth level</a:t>
             </a:r>
-            <a:endParaRPr lang="en-US"/>
           </a:p>
         </p:txBody>
       </p:sp>
@@ -473,7 +488,7 @@
           <a:p>
             <a:fld id="{5BCAD085-E8A6-8845-BD4E-CB4CCA059FC4}" type="datetimeFigureOut">
               <a:rPr lang="en-US" smtClean="0"/>
-              <a:t>1/27/13</a:t>
+              <a:t>4/23/2026</a:t>
             </a:fld>
             <a:endParaRPr lang="en-US"/>
           </a:p>
@@ -515,7 +530,7 @@
           <a:p>
             <a:fld id="{C1FF6DA9-008F-8B48-92A6-B652298478BF}" type="slidenum">
               <a:rPr lang="en-US" smtClean="0"/>
-              <a:t>‹#›</a:t>
+              <a:t>‹Nº›</a:t>
             </a:fld>
             <a:endParaRPr lang="en-US"/>
           </a:p>
@@ -572,10 +587,9 @@
           <a:lstStyle/>
           <a:p>
             <a:r>
-              <a:rPr lang="en-US" smtClean="0"/>
+              <a:rPr lang="en-US"/>
               <a:t>Click to edit Master title style</a:t>
             </a:r>
-            <a:endParaRPr lang="en-US"/>
           </a:p>
         </p:txBody>
       </p:sp>
@@ -601,38 +615,37 @@
           <a:p>
             <a:pPr lvl="0"/>
             <a:r>
-              <a:rPr lang="en-US" smtClean="0"/>
+              <a:rPr lang="en-US"/>
               <a:t>Click to edit Master text styles</a:t>
             </a:r>
           </a:p>
           <a:p>
             <a:pPr lvl="1"/>
             <a:r>
-              <a:rPr lang="en-US" smtClean="0"/>
+              <a:rPr lang="en-US"/>
               <a:t>Second level</a:t>
             </a:r>
           </a:p>
           <a:p>
             <a:pPr lvl="2"/>
             <a:r>
-              <a:rPr lang="en-US" smtClean="0"/>
+              <a:rPr lang="en-US"/>
               <a:t>Third level</a:t>
             </a:r>
           </a:p>
           <a:p>
             <a:pPr lvl="3"/>
             <a:r>
-              <a:rPr lang="en-US" smtClean="0"/>
+              <a:rPr lang="en-US"/>
               <a:t>Fourth level</a:t>
             </a:r>
           </a:p>
           <a:p>
             <a:pPr lvl="4"/>
             <a:r>
-              <a:rPr lang="en-US" smtClean="0"/>
+              <a:rPr lang="en-US"/>
               <a:t>Fifth level</a:t>
             </a:r>
-            <a:endParaRPr lang="en-US"/>
           </a:p>
         </p:txBody>
       </p:sp>
@@ -653,7 +666,7 @@
           <a:p>
             <a:fld id="{5BCAD085-E8A6-8845-BD4E-CB4CCA059FC4}" type="datetimeFigureOut">
               <a:rPr lang="en-US" smtClean="0"/>
-              <a:t>1/27/13</a:t>
+              <a:t>4/23/2026</a:t>
             </a:fld>
             <a:endParaRPr lang="en-US"/>
           </a:p>
@@ -695,7 +708,7 @@
           <a:p>
             <a:fld id="{C1FF6DA9-008F-8B48-92A6-B652298478BF}" type="slidenum">
               <a:rPr lang="en-US" smtClean="0"/>
-              <a:t>‹#›</a:t>
+              <a:t>‹Nº›</a:t>
             </a:fld>
             <a:endParaRPr lang="en-US"/>
           </a:p>
@@ -747,10 +760,9 @@
           <a:lstStyle/>
           <a:p>
             <a:r>
-              <a:rPr lang="en-US" smtClean="0"/>
+              <a:rPr lang="en-US"/>
               <a:t>Click to edit Master title style</a:t>
             </a:r>
-            <a:endParaRPr lang="en-US"/>
           </a:p>
         </p:txBody>
       </p:sp>
@@ -771,38 +783,37 @@
           <a:p>
             <a:pPr lvl="0"/>
             <a:r>
-              <a:rPr lang="en-US" smtClean="0"/>
+              <a:rPr lang="en-US"/>
               <a:t>Click to edit Master text styles</a:t>
             </a:r>
           </a:p>
           <a:p>
             <a:pPr lvl="1"/>
             <a:r>
-              <a:rPr lang="en-US" smtClean="0"/>
+              <a:rPr lang="en-US"/>
               <a:t>Second level</a:t>
             </a:r>
           </a:p>
           <a:p>
             <a:pPr lvl="2"/>
             <a:r>
-              <a:rPr lang="en-US" smtClean="0"/>
+              <a:rPr lang="en-US"/>
               <a:t>Third level</a:t>
             </a:r>
           </a:p>
           <a:p>
             <a:pPr lvl="3"/>
             <a:r>
-              <a:rPr lang="en-US" smtClean="0"/>
+              <a:rPr lang="en-US"/>
               <a:t>Fourth level</a:t>
             </a:r>
           </a:p>
           <a:p>
             <a:pPr lvl="4"/>
             <a:r>
-              <a:rPr lang="en-US" smtClean="0"/>
+              <a:rPr lang="en-US"/>
               <a:t>Fifth level</a:t>
             </a:r>
-            <a:endParaRPr lang="en-US"/>
           </a:p>
         </p:txBody>
       </p:sp>
@@ -823,7 +834,7 @@
           <a:p>
             <a:fld id="{5BCAD085-E8A6-8845-BD4E-CB4CCA059FC4}" type="datetimeFigureOut">
               <a:rPr lang="en-US" smtClean="0"/>
-              <a:t>1/27/13</a:t>
+              <a:t>4/23/2026</a:t>
             </a:fld>
             <a:endParaRPr lang="en-US"/>
           </a:p>
@@ -865,7 +876,7 @@
           <a:p>
             <a:fld id="{C1FF6DA9-008F-8B48-92A6-B652298478BF}" type="slidenum">
               <a:rPr lang="en-US" smtClean="0"/>
-              <a:t>‹#›</a:t>
+              <a:t>‹Nº›</a:t>
             </a:fld>
             <a:endParaRPr lang="en-US"/>
           </a:p>
@@ -926,10 +937,9 @@
           </a:lstStyle>
           <a:p>
             <a:r>
-              <a:rPr lang="en-US" smtClean="0"/>
+              <a:rPr lang="en-US"/>
               <a:t>Click to edit Master title style</a:t>
             </a:r>
-            <a:endParaRPr lang="en-US"/>
           </a:p>
         </p:txBody>
       </p:sp>
@@ -1046,7 +1056,7 @@
           <a:p>
             <a:pPr lvl="0"/>
             <a:r>
-              <a:rPr lang="en-US" smtClean="0"/>
+              <a:rPr lang="en-US"/>
               <a:t>Click to edit Master text styles</a:t>
             </a:r>
           </a:p>
@@ -1069,7 +1079,7 @@
           <a:p>
             <a:fld id="{5BCAD085-E8A6-8845-BD4E-CB4CCA059FC4}" type="datetimeFigureOut">
               <a:rPr lang="en-US" smtClean="0"/>
-              <a:t>1/27/13</a:t>
+              <a:t>4/23/2026</a:t>
             </a:fld>
             <a:endParaRPr lang="en-US"/>
           </a:p>
@@ -1111,7 +1121,7 @@
           <a:p>
             <a:fld id="{C1FF6DA9-008F-8B48-92A6-B652298478BF}" type="slidenum">
               <a:rPr lang="en-US" smtClean="0"/>
-              <a:t>‹#›</a:t>
+              <a:t>‹Nº›</a:t>
             </a:fld>
             <a:endParaRPr lang="en-US"/>
           </a:p>
@@ -1163,10 +1173,9 @@
           <a:lstStyle/>
           <a:p>
             <a:r>
-              <a:rPr lang="en-US" smtClean="0"/>
+              <a:rPr lang="en-US"/>
               <a:t>Click to edit Master title style</a:t>
             </a:r>
-            <a:endParaRPr lang="en-US"/>
           </a:p>
         </p:txBody>
       </p:sp>
@@ -1220,38 +1229,37 @@
           <a:p>
             <a:pPr lvl="0"/>
             <a:r>
-              <a:rPr lang="en-US" smtClean="0"/>
+              <a:rPr lang="en-US"/>
               <a:t>Click to edit Master text styles</a:t>
             </a:r>
           </a:p>
           <a:p>
             <a:pPr lvl="1"/>
             <a:r>
-              <a:rPr lang="en-US" smtClean="0"/>
+              <a:rPr lang="en-US"/>
               <a:t>Second level</a:t>
             </a:r>
           </a:p>
           <a:p>
             <a:pPr lvl="2"/>
             <a:r>
-              <a:rPr lang="en-US" smtClean="0"/>
+              <a:rPr lang="en-US"/>
               <a:t>Third level</a:t>
             </a:r>
           </a:p>
           <a:p>
             <a:pPr lvl="3"/>
             <a:r>
-              <a:rPr lang="en-US" smtClean="0"/>
+              <a:rPr lang="en-US"/>
               <a:t>Fourth level</a:t>
             </a:r>
           </a:p>
           <a:p>
             <a:pPr lvl="4"/>
             <a:r>
-              <a:rPr lang="en-US" smtClean="0"/>
+              <a:rPr lang="en-US"/>
               <a:t>Fifth level</a:t>
             </a:r>
-            <a:endParaRPr lang="en-US"/>
           </a:p>
         </p:txBody>
       </p:sp>
@@ -1305,38 +1313,37 @@
           <a:p>
             <a:pPr lvl="0"/>
             <a:r>
-              <a:rPr lang="en-US" smtClean="0"/>
+              <a:rPr lang="en-US"/>
               <a:t>Click to edit Master text styles</a:t>
             </a:r>
           </a:p>
           <a:p>
             <a:pPr lvl="1"/>
             <a:r>
-              <a:rPr lang="en-US" smtClean="0"/>
+              <a:rPr lang="en-US"/>
               <a:t>Second level</a:t>
             </a:r>
           </a:p>
           <a:p>
             <a:pPr lvl="2"/>
             <a:r>
-              <a:rPr lang="en-US" smtClean="0"/>
+              <a:rPr lang="en-US"/>
               <a:t>Third level</a:t>
             </a:r>
           </a:p>
           <a:p>
             <a:pPr lvl="3"/>
             <a:r>
-              <a:rPr lang="en-US" smtClean="0"/>
+              <a:rPr lang="en-US"/>
               <a:t>Fourth level</a:t>
             </a:r>
           </a:p>
           <a:p>
             <a:pPr lvl="4"/>
             <a:r>
-              <a:rPr lang="en-US" smtClean="0"/>
+              <a:rPr lang="en-US"/>
               <a:t>Fifth level</a:t>
             </a:r>
-            <a:endParaRPr lang="en-US"/>
           </a:p>
         </p:txBody>
       </p:sp>
@@ -1357,7 +1364,7 @@
           <a:p>
             <a:fld id="{5BCAD085-E8A6-8845-BD4E-CB4CCA059FC4}" type="datetimeFigureOut">
               <a:rPr lang="en-US" smtClean="0"/>
-              <a:t>1/27/13</a:t>
+              <a:t>4/23/2026</a:t>
             </a:fld>
             <a:endParaRPr lang="en-US"/>
           </a:p>
@@ -1399,7 +1406,7 @@
           <a:p>
             <a:fld id="{C1FF6DA9-008F-8B48-92A6-B652298478BF}" type="slidenum">
               <a:rPr lang="en-US" smtClean="0"/>
-              <a:t>‹#›</a:t>
+              <a:t>‹Nº›</a:t>
             </a:fld>
             <a:endParaRPr lang="en-US"/>
           </a:p>
@@ -1455,10 +1462,9 @@
           </a:lstStyle>
           <a:p>
             <a:r>
-              <a:rPr lang="en-US" smtClean="0"/>
+              <a:rPr lang="en-US"/>
               <a:t>Click to edit Master title style</a:t>
             </a:r>
-            <a:endParaRPr lang="en-US"/>
           </a:p>
         </p:txBody>
       </p:sp>
@@ -1521,7 +1527,7 @@
           <a:p>
             <a:pPr lvl="0"/>
             <a:r>
-              <a:rPr lang="en-US" smtClean="0"/>
+              <a:rPr lang="en-US"/>
               <a:t>Click to edit Master text styles</a:t>
             </a:r>
           </a:p>
@@ -1577,38 +1583,37 @@
           <a:p>
             <a:pPr lvl="0"/>
             <a:r>
-              <a:rPr lang="en-US" smtClean="0"/>
+              <a:rPr lang="en-US"/>
               <a:t>Click to edit Master text styles</a:t>
             </a:r>
           </a:p>
           <a:p>
             <a:pPr lvl="1"/>
             <a:r>
-              <a:rPr lang="en-US" smtClean="0"/>
+              <a:rPr lang="en-US"/>
               <a:t>Second level</a:t>
             </a:r>
           </a:p>
           <a:p>
             <a:pPr lvl="2"/>
             <a:r>
-              <a:rPr lang="en-US" smtClean="0"/>
+              <a:rPr lang="en-US"/>
               <a:t>Third level</a:t>
             </a:r>
           </a:p>
           <a:p>
             <a:pPr lvl="3"/>
             <a:r>
-              <a:rPr lang="en-US" smtClean="0"/>
+              <a:rPr lang="en-US"/>
               <a:t>Fourth level</a:t>
             </a:r>
           </a:p>
           <a:p>
             <a:pPr lvl="4"/>
             <a:r>
-              <a:rPr lang="en-US" smtClean="0"/>
+              <a:rPr lang="en-US"/>
               <a:t>Fifth level</a:t>
             </a:r>
-            <a:endParaRPr lang="en-US"/>
           </a:p>
         </p:txBody>
       </p:sp>
@@ -1671,7 +1676,7 @@
           <a:p>
             <a:pPr lvl="0"/>
             <a:r>
-              <a:rPr lang="en-US" smtClean="0"/>
+              <a:rPr lang="en-US"/>
               <a:t>Click to edit Master text styles</a:t>
             </a:r>
           </a:p>
@@ -1727,38 +1732,37 @@
           <a:p>
             <a:pPr lvl="0"/>
             <a:r>
-              <a:rPr lang="en-US" smtClean="0"/>
+              <a:rPr lang="en-US"/>
               <a:t>Click to edit Master text styles</a:t>
             </a:r>
           </a:p>
           <a:p>
             <a:pPr lvl="1"/>
             <a:r>
-              <a:rPr lang="en-US" smtClean="0"/>
+              <a:rPr lang="en-US"/>
               <a:t>Second level</a:t>
             </a:r>
           </a:p>
           <a:p>
             <a:pPr lvl="2"/>
             <a:r>
-              <a:rPr lang="en-US" smtClean="0"/>
+              <a:rPr lang="en-US"/>
               <a:t>Third level</a:t>
             </a:r>
           </a:p>
           <a:p>
             <a:pPr lvl="3"/>
             <a:r>
-              <a:rPr lang="en-US" smtClean="0"/>
+              <a:rPr lang="en-US"/>
               <a:t>Fourth level</a:t>
             </a:r>
           </a:p>
           <a:p>
             <a:pPr lvl="4"/>
             <a:r>
-              <a:rPr lang="en-US" smtClean="0"/>
+              <a:rPr lang="en-US"/>
               <a:t>Fifth level</a:t>
             </a:r>
-            <a:endParaRPr lang="en-US"/>
           </a:p>
         </p:txBody>
       </p:sp>
@@ -1779,7 +1783,7 @@
           <a:p>
             <a:fld id="{5BCAD085-E8A6-8845-BD4E-CB4CCA059FC4}" type="datetimeFigureOut">
               <a:rPr lang="en-US" smtClean="0"/>
-              <a:t>1/27/13</a:t>
+              <a:t>4/23/2026</a:t>
             </a:fld>
             <a:endParaRPr lang="en-US"/>
           </a:p>
@@ -1821,7 +1825,7 @@
           <a:p>
             <a:fld id="{C1FF6DA9-008F-8B48-92A6-B652298478BF}" type="slidenum">
               <a:rPr lang="en-US" smtClean="0"/>
-              <a:t>‹#›</a:t>
+              <a:t>‹Nº›</a:t>
             </a:fld>
             <a:endParaRPr lang="en-US"/>
           </a:p>
@@ -1873,10 +1877,9 @@
           <a:lstStyle/>
           <a:p>
             <a:r>
-              <a:rPr lang="en-US" smtClean="0"/>
+              <a:rPr lang="en-US"/>
               <a:t>Click to edit Master title style</a:t>
             </a:r>
-            <a:endParaRPr lang="en-US"/>
           </a:p>
         </p:txBody>
       </p:sp>
@@ -1897,7 +1900,7 @@
           <a:p>
             <a:fld id="{5BCAD085-E8A6-8845-BD4E-CB4CCA059FC4}" type="datetimeFigureOut">
               <a:rPr lang="en-US" smtClean="0"/>
-              <a:t>1/27/13</a:t>
+              <a:t>4/23/2026</a:t>
             </a:fld>
             <a:endParaRPr lang="en-US"/>
           </a:p>
@@ -1939,7 +1942,7 @@
           <a:p>
             <a:fld id="{C1FF6DA9-008F-8B48-92A6-B652298478BF}" type="slidenum">
               <a:rPr lang="en-US" smtClean="0"/>
-              <a:t>‹#›</a:t>
+              <a:t>‹Nº›</a:t>
             </a:fld>
             <a:endParaRPr lang="en-US"/>
           </a:p>
@@ -1992,7 +1995,7 @@
           <a:p>
             <a:fld id="{5BCAD085-E8A6-8845-BD4E-CB4CCA059FC4}" type="datetimeFigureOut">
               <a:rPr lang="en-US" smtClean="0"/>
-              <a:t>1/27/13</a:t>
+              <a:t>4/23/2026</a:t>
             </a:fld>
             <a:endParaRPr lang="en-US"/>
           </a:p>
@@ -2034,7 +2037,7 @@
           <a:p>
             <a:fld id="{C1FF6DA9-008F-8B48-92A6-B652298478BF}" type="slidenum">
               <a:rPr lang="en-US" smtClean="0"/>
-              <a:t>‹#›</a:t>
+              <a:t>‹Nº›</a:t>
             </a:fld>
             <a:endParaRPr lang="en-US"/>
           </a:p>
@@ -2095,10 +2098,9 @@
           </a:lstStyle>
           <a:p>
             <a:r>
-              <a:rPr lang="en-US" smtClean="0"/>
+              <a:rPr lang="en-US"/>
               <a:t>Click to edit Master title style</a:t>
             </a:r>
-            <a:endParaRPr lang="en-US"/>
           </a:p>
         </p:txBody>
       </p:sp>
@@ -2152,38 +2154,37 @@
           <a:p>
             <a:pPr lvl="0"/>
             <a:r>
-              <a:rPr lang="en-US" smtClean="0"/>
+              <a:rPr lang="en-US"/>
               <a:t>Click to edit Master text styles</a:t>
             </a:r>
           </a:p>
           <a:p>
             <a:pPr lvl="1"/>
             <a:r>
-              <a:rPr lang="en-US" smtClean="0"/>
+              <a:rPr lang="en-US"/>
               <a:t>Second level</a:t>
             </a:r>
           </a:p>
           <a:p>
             <a:pPr lvl="2"/>
             <a:r>
-              <a:rPr lang="en-US" smtClean="0"/>
+              <a:rPr lang="en-US"/>
               <a:t>Third level</a:t>
             </a:r>
           </a:p>
           <a:p>
             <a:pPr lvl="3"/>
             <a:r>
-              <a:rPr lang="en-US" smtClean="0"/>
+              <a:rPr lang="en-US"/>
               <a:t>Fourth level</a:t>
             </a:r>
           </a:p>
           <a:p>
             <a:pPr lvl="4"/>
             <a:r>
-              <a:rPr lang="en-US" smtClean="0"/>
+              <a:rPr lang="en-US"/>
               <a:t>Fifth level</a:t>
             </a:r>
-            <a:endParaRPr lang="en-US"/>
           </a:p>
         </p:txBody>
       </p:sp>
@@ -2246,7 +2247,7 @@
           <a:p>
             <a:pPr lvl="0"/>
             <a:r>
-              <a:rPr lang="en-US" smtClean="0"/>
+              <a:rPr lang="en-US"/>
               <a:t>Click to edit Master text styles</a:t>
             </a:r>
           </a:p>
@@ -2269,7 +2270,7 @@
           <a:p>
             <a:fld id="{5BCAD085-E8A6-8845-BD4E-CB4CCA059FC4}" type="datetimeFigureOut">
               <a:rPr lang="en-US" smtClean="0"/>
-              <a:t>1/27/13</a:t>
+              <a:t>4/23/2026</a:t>
             </a:fld>
             <a:endParaRPr lang="en-US"/>
           </a:p>
@@ -2311,7 +2312,7 @@
           <a:p>
             <a:fld id="{C1FF6DA9-008F-8B48-92A6-B652298478BF}" type="slidenum">
               <a:rPr lang="en-US" smtClean="0"/>
-              <a:t>‹#›</a:t>
+              <a:t>‹Nº›</a:t>
             </a:fld>
             <a:endParaRPr lang="en-US"/>
           </a:p>
@@ -2372,10 +2373,9 @@
           </a:lstStyle>
           <a:p>
             <a:r>
-              <a:rPr lang="en-US" smtClean="0"/>
+              <a:rPr lang="en-US"/>
               <a:t>Click to edit Master title style</a:t>
             </a:r>
-            <a:endParaRPr lang="en-US"/>
           </a:p>
         </p:txBody>
       </p:sp>
@@ -2499,7 +2499,7 @@
           <a:p>
             <a:pPr lvl="0"/>
             <a:r>
-              <a:rPr lang="en-US" smtClean="0"/>
+              <a:rPr lang="en-US"/>
               <a:t>Click to edit Master text styles</a:t>
             </a:r>
           </a:p>
@@ -2522,7 +2522,7 @@
           <a:p>
             <a:fld id="{5BCAD085-E8A6-8845-BD4E-CB4CCA059FC4}" type="datetimeFigureOut">
               <a:rPr lang="en-US" smtClean="0"/>
-              <a:t>1/27/13</a:t>
+              <a:t>4/23/2026</a:t>
             </a:fld>
             <a:endParaRPr lang="en-US"/>
           </a:p>
@@ -2564,7 +2564,7 @@
           <a:p>
             <a:fld id="{C1FF6DA9-008F-8B48-92A6-B652298478BF}" type="slidenum">
               <a:rPr lang="en-US" smtClean="0"/>
-              <a:t>‹#›</a:t>
+              <a:t>‹Nº›</a:t>
             </a:fld>
             <a:endParaRPr lang="en-US"/>
           </a:p>
@@ -2631,10 +2631,9 @@
           <a:lstStyle/>
           <a:p>
             <a:r>
-              <a:rPr lang="en-US" smtClean="0"/>
+              <a:rPr lang="en-US"/>
               <a:t>Click to edit Master title style</a:t>
             </a:r>
-            <a:endParaRPr lang="en-US"/>
           </a:p>
         </p:txBody>
       </p:sp>
@@ -2665,38 +2664,37 @@
           <a:p>
             <a:pPr lvl="0"/>
             <a:r>
-              <a:rPr lang="en-US" smtClean="0"/>
+              <a:rPr lang="en-US"/>
               <a:t>Click to edit Master text styles</a:t>
             </a:r>
           </a:p>
           <a:p>
             <a:pPr lvl="1"/>
             <a:r>
-              <a:rPr lang="en-US" smtClean="0"/>
+              <a:rPr lang="en-US"/>
               <a:t>Second level</a:t>
             </a:r>
           </a:p>
           <a:p>
             <a:pPr lvl="2"/>
             <a:r>
-              <a:rPr lang="en-US" smtClean="0"/>
+              <a:rPr lang="en-US"/>
               <a:t>Third level</a:t>
             </a:r>
           </a:p>
           <a:p>
             <a:pPr lvl="3"/>
             <a:r>
-              <a:rPr lang="en-US" smtClean="0"/>
+              <a:rPr lang="en-US"/>
               <a:t>Fourth level</a:t>
             </a:r>
           </a:p>
           <a:p>
             <a:pPr lvl="4"/>
             <a:r>
-              <a:rPr lang="en-US" smtClean="0"/>
+              <a:rPr lang="en-US"/>
               <a:t>Fifth level</a:t>
             </a:r>
-            <a:endParaRPr lang="en-US"/>
           </a:p>
         </p:txBody>
       </p:sp>
@@ -2735,7 +2733,7 @@
           <a:p>
             <a:fld id="{5BCAD085-E8A6-8845-BD4E-CB4CCA059FC4}" type="datetimeFigureOut">
               <a:rPr lang="en-US" smtClean="0"/>
-              <a:t>1/27/13</a:t>
+              <a:t>4/23/2026</a:t>
             </a:fld>
             <a:endParaRPr lang="en-US"/>
           </a:p>
@@ -2813,7 +2811,7 @@
           <a:p>
             <a:fld id="{C1FF6DA9-008F-8B48-92A6-B652298478BF}" type="slidenum">
               <a:rPr lang="en-US" smtClean="0"/>
-              <a:t>‹#›</a:t>
+              <a:t>‹Nº›</a:t>
             </a:fld>
             <a:endParaRPr lang="en-US"/>
           </a:p>
@@ -3094,7 +3092,7 @@
 </file>
 
 <file path=ppt/slides/slide1.xml><?xml version="1.0" encoding="utf-8"?>
-<p:sld xmlns:a="http://schemas.openxmlformats.org/drawingml/2006/main" xmlns:p="http://schemas.openxmlformats.org/presentationml/2006/main" xmlns:r="http://schemas.openxmlformats.org/officeDocument/2006/relationships">
+<p:sld xmlns:a="http://schemas.openxmlformats.org/drawingml/2006/main" xmlns:r="http://schemas.openxmlformats.org/officeDocument/2006/relationships" xmlns:p="http://schemas.openxmlformats.org/presentationml/2006/main">
   <p:cSld>
     <p:spTree>
       <p:nvGrpSpPr>
@@ -3102,7 +3100,14 @@
         <p:cNvGrpSpPr/>
         <p:nvPr/>
       </p:nvGrpSpPr>
-      <p:grpSpPr/>
+      <p:grpSpPr>
+        <a:xfrm>
+          <a:off x="0" y="0"/>
+          <a:ext cx="0" cy="0"/>
+          <a:chOff x="0" y="0"/>
+          <a:chExt cx="0" cy="0"/>
+        </a:xfrm>
+      </p:grpSpPr>
       <p:sp>
         <p:nvSpPr>
           <p:cNvPr id="2" name="Rectangle 1"/>
@@ -3143,6 +3148,7 @@
           <a:lstStyle/>
           <a:p>
             <a:pPr algn="ctr"/>
+            <a:endParaRPr/>
           </a:p>
         </p:txBody>
       </p:sp>
@@ -3186,6 +3192,7 @@
           <a:lstStyle/>
           <a:p>
             <a:pPr algn="ctr"/>
+            <a:endParaRPr/>
           </a:p>
         </p:txBody>
       </p:sp>
@@ -3304,7 +3311,7 @@
 </file>
 
 <file path=ppt/slides/slide10.xml><?xml version="1.0" encoding="utf-8"?>
-<p:sld xmlns:a="http://schemas.openxmlformats.org/drawingml/2006/main" xmlns:p="http://schemas.openxmlformats.org/presentationml/2006/main" xmlns:r="http://schemas.openxmlformats.org/officeDocument/2006/relationships">
+<p:sld xmlns:a="http://schemas.openxmlformats.org/drawingml/2006/main" xmlns:r="http://schemas.openxmlformats.org/officeDocument/2006/relationships" xmlns:p="http://schemas.openxmlformats.org/presentationml/2006/main">
   <p:cSld>
     <p:spTree>
       <p:nvGrpSpPr>
@@ -3312,7 +3319,14 @@
         <p:cNvGrpSpPr/>
         <p:nvPr/>
       </p:nvGrpSpPr>
-      <p:grpSpPr/>
+      <p:grpSpPr>
+        <a:xfrm>
+          <a:off x="0" y="0"/>
+          <a:ext cx="0" cy="0"/>
+          <a:chOff x="0" y="0"/>
+          <a:chExt cx="0" cy="0"/>
+        </a:xfrm>
+      </p:grpSpPr>
       <p:sp>
         <p:nvSpPr>
           <p:cNvPr id="2" name="Rectangle 1"/>
@@ -3353,6 +3367,7 @@
           <a:lstStyle/>
           <a:p>
             <a:pPr algn="ctr"/>
+            <a:endParaRPr/>
           </a:p>
         </p:txBody>
       </p:sp>
@@ -3430,6 +3445,7 @@
           <a:lstStyle/>
           <a:p>
             <a:pPr algn="ctr"/>
+            <a:endParaRPr/>
           </a:p>
         </p:txBody>
       </p:sp>
@@ -3498,6 +3514,7 @@
                 <a:latin typeface="Calibri"/>
               </a:defRPr>
             </a:pPr>
+            <a:endParaRPr/>
           </a:p>
           <a:p>
             <a:pPr>
@@ -3543,6 +3560,7 @@
                 <a:latin typeface="Calibri"/>
               </a:defRPr>
             </a:pPr>
+            <a:endParaRPr/>
           </a:p>
           <a:p>
             <a:pPr>
@@ -3587,7 +3605,7 @@
 </file>
 
 <file path=ppt/slides/slide11.xml><?xml version="1.0" encoding="utf-8"?>
-<p:sld xmlns:a="http://schemas.openxmlformats.org/drawingml/2006/main" xmlns:p="http://schemas.openxmlformats.org/presentationml/2006/main" xmlns:r="http://schemas.openxmlformats.org/officeDocument/2006/relationships">
+<p:sld xmlns:a="http://schemas.openxmlformats.org/drawingml/2006/main" xmlns:r="http://schemas.openxmlformats.org/officeDocument/2006/relationships" xmlns:p="http://schemas.openxmlformats.org/presentationml/2006/main">
   <p:cSld>
     <p:spTree>
       <p:nvGrpSpPr>
@@ -3595,7 +3613,14 @@
         <p:cNvGrpSpPr/>
         <p:nvPr/>
       </p:nvGrpSpPr>
-      <p:grpSpPr/>
+      <p:grpSpPr>
+        <a:xfrm>
+          <a:off x="0" y="0"/>
+          <a:ext cx="0" cy="0"/>
+          <a:chOff x="0" y="0"/>
+          <a:chExt cx="0" cy="0"/>
+        </a:xfrm>
+      </p:grpSpPr>
       <p:sp>
         <p:nvSpPr>
           <p:cNvPr id="2" name="Rectangle 1"/>
@@ -3636,6 +3661,7 @@
           <a:lstStyle/>
           <a:p>
             <a:pPr algn="ctr"/>
+            <a:endParaRPr/>
           </a:p>
         </p:txBody>
       </p:sp>
@@ -3713,6 +3739,7 @@
           <a:lstStyle/>
           <a:p>
             <a:pPr algn="ctr"/>
+            <a:endParaRPr/>
           </a:p>
         </p:txBody>
       </p:sp>
@@ -3735,9 +3762,27 @@
                 <a:tableStyleId>{5C22544A-7EE6-4342-B048-85BDC9FD1C3A}</a:tableStyleId>
               </a:tblPr>
               <a:tblGrid>
-                <a:gridCol w="3505200"/>
-                <a:gridCol w="3505200"/>
-                <a:gridCol w="3505200"/>
+                <a:gridCol w="3505200">
+                  <a:extLst>
+                    <a:ext uri="{9D8B030D-6E8A-4147-A177-3AD203B41FA5}">
+                      <a16:colId xmlns:a16="http://schemas.microsoft.com/office/drawing/2014/main" val="20000"/>
+                    </a:ext>
+                  </a:extLst>
+                </a:gridCol>
+                <a:gridCol w="3505200">
+                  <a:extLst>
+                    <a:ext uri="{9D8B030D-6E8A-4147-A177-3AD203B41FA5}">
+                      <a16:colId xmlns:a16="http://schemas.microsoft.com/office/drawing/2014/main" val="20001"/>
+                    </a:ext>
+                  </a:extLst>
+                </a:gridCol>
+                <a:gridCol w="3505200">
+                  <a:extLst>
+                    <a:ext uri="{9D8B030D-6E8A-4147-A177-3AD203B41FA5}">
+                      <a16:colId xmlns:a16="http://schemas.microsoft.com/office/drawing/2014/main" val="20002"/>
+                    </a:ext>
+                  </a:extLst>
+                </a:gridCol>
               </a:tblGrid>
               <a:tr h="411480">
                 <a:tc>
@@ -3812,6 +3857,11 @@
                     </a:solidFill>
                   </a:tcPr>
                 </a:tc>
+                <a:extLst>
+                  <a:ext uri="{0D108BD9-81ED-4DB2-BD59-A6C34878D82A}">
+                    <a16:rowId xmlns:a16="http://schemas.microsoft.com/office/drawing/2014/main" val="10000"/>
+                  </a:ext>
+                </a:extLst>
               </a:tr>
               <a:tr h="411480">
                 <a:tc>
@@ -3886,6 +3936,11 @@
                     </a:solidFill>
                   </a:tcPr>
                 </a:tc>
+                <a:extLst>
+                  <a:ext uri="{0D108BD9-81ED-4DB2-BD59-A6C34878D82A}">
+                    <a16:rowId xmlns:a16="http://schemas.microsoft.com/office/drawing/2014/main" val="10001"/>
+                  </a:ext>
+                </a:extLst>
               </a:tr>
               <a:tr h="411480">
                 <a:tc>
@@ -3948,6 +4003,11 @@
                   </a:txBody>
                   <a:tcPr/>
                 </a:tc>
+                <a:extLst>
+                  <a:ext uri="{0D108BD9-81ED-4DB2-BD59-A6C34878D82A}">
+                    <a16:rowId xmlns:a16="http://schemas.microsoft.com/office/drawing/2014/main" val="10002"/>
+                  </a:ext>
+                </a:extLst>
               </a:tr>
               <a:tr h="411480">
                 <a:tc>
@@ -4022,6 +4082,11 @@
                     </a:solidFill>
                   </a:tcPr>
                 </a:tc>
+                <a:extLst>
+                  <a:ext uri="{0D108BD9-81ED-4DB2-BD59-A6C34878D82A}">
+                    <a16:rowId xmlns:a16="http://schemas.microsoft.com/office/drawing/2014/main" val="10003"/>
+                  </a:ext>
+                </a:extLst>
               </a:tr>
               <a:tr h="411480">
                 <a:tc>
@@ -4084,6 +4149,11 @@
                   </a:txBody>
                   <a:tcPr/>
                 </a:tc>
+                <a:extLst>
+                  <a:ext uri="{0D108BD9-81ED-4DB2-BD59-A6C34878D82A}">
+                    <a16:rowId xmlns:a16="http://schemas.microsoft.com/office/drawing/2014/main" val="10004"/>
+                  </a:ext>
+                </a:extLst>
               </a:tr>
               <a:tr h="411480">
                 <a:tc>
@@ -4158,6 +4228,11 @@
                     </a:solidFill>
                   </a:tcPr>
                 </a:tc>
+                <a:extLst>
+                  <a:ext uri="{0D108BD9-81ED-4DB2-BD59-A6C34878D82A}">
+                    <a16:rowId xmlns:a16="http://schemas.microsoft.com/office/drawing/2014/main" val="10005"/>
+                  </a:ext>
+                </a:extLst>
               </a:tr>
               <a:tr h="411480">
                 <a:tc>
@@ -4220,6 +4295,11 @@
                   </a:txBody>
                   <a:tcPr/>
                 </a:tc>
+                <a:extLst>
+                  <a:ext uri="{0D108BD9-81ED-4DB2-BD59-A6C34878D82A}">
+                    <a16:rowId xmlns:a16="http://schemas.microsoft.com/office/drawing/2014/main" val="10006"/>
+                  </a:ext>
+                </a:extLst>
               </a:tr>
             </a:tbl>
           </a:graphicData>
@@ -4234,7 +4314,7 @@
 </file>
 
 <file path=ppt/slides/slide12.xml><?xml version="1.0" encoding="utf-8"?>
-<p:sld xmlns:a="http://schemas.openxmlformats.org/drawingml/2006/main" xmlns:p="http://schemas.openxmlformats.org/presentationml/2006/main" xmlns:r="http://schemas.openxmlformats.org/officeDocument/2006/relationships">
+<p:sld xmlns:a="http://schemas.openxmlformats.org/drawingml/2006/main" xmlns:r="http://schemas.openxmlformats.org/officeDocument/2006/relationships" xmlns:p="http://schemas.openxmlformats.org/presentationml/2006/main">
   <p:cSld>
     <p:spTree>
       <p:nvGrpSpPr>
@@ -4242,7 +4322,14 @@
         <p:cNvGrpSpPr/>
         <p:nvPr/>
       </p:nvGrpSpPr>
-      <p:grpSpPr/>
+      <p:grpSpPr>
+        <a:xfrm>
+          <a:off x="0" y="0"/>
+          <a:ext cx="0" cy="0"/>
+          <a:chOff x="0" y="0"/>
+          <a:chExt cx="0" cy="0"/>
+        </a:xfrm>
+      </p:grpSpPr>
       <p:sp>
         <p:nvSpPr>
           <p:cNvPr id="2" name="Rectangle 1"/>
@@ -4283,6 +4370,7 @@
           <a:lstStyle/>
           <a:p>
             <a:pPr algn="ctr"/>
+            <a:endParaRPr/>
           </a:p>
         </p:txBody>
       </p:sp>
@@ -4360,6 +4448,7 @@
           <a:lstStyle/>
           <a:p>
             <a:pPr algn="ctr"/>
+            <a:endParaRPr/>
           </a:p>
         </p:txBody>
       </p:sp>
@@ -4412,6 +4501,7 @@
                 <a:latin typeface="Calibri"/>
               </a:defRPr>
             </a:pPr>
+            <a:endParaRPr/>
           </a:p>
           <a:p>
             <a:pPr>
@@ -4505,6 +4595,7 @@
                 <a:latin typeface="Calibri"/>
               </a:defRPr>
             </a:pPr>
+            <a:endParaRPr/>
           </a:p>
           <a:p>
             <a:pPr>
@@ -4549,7 +4640,7 @@
 </file>
 
 <file path=ppt/slides/slide13.xml><?xml version="1.0" encoding="utf-8"?>
-<p:sld xmlns:a="http://schemas.openxmlformats.org/drawingml/2006/main" xmlns:p="http://schemas.openxmlformats.org/presentationml/2006/main" xmlns:r="http://schemas.openxmlformats.org/officeDocument/2006/relationships">
+<p:sld xmlns:a="http://schemas.openxmlformats.org/drawingml/2006/main" xmlns:r="http://schemas.openxmlformats.org/officeDocument/2006/relationships" xmlns:p="http://schemas.openxmlformats.org/presentationml/2006/main">
   <p:cSld>
     <p:spTree>
       <p:nvGrpSpPr>
@@ -4557,7 +4648,14 @@
         <p:cNvGrpSpPr/>
         <p:nvPr/>
       </p:nvGrpSpPr>
-      <p:grpSpPr/>
+      <p:grpSpPr>
+        <a:xfrm>
+          <a:off x="0" y="0"/>
+          <a:ext cx="0" cy="0"/>
+          <a:chOff x="0" y="0"/>
+          <a:chExt cx="0" cy="0"/>
+        </a:xfrm>
+      </p:grpSpPr>
       <p:sp>
         <p:nvSpPr>
           <p:cNvPr id="2" name="Rectangle 1"/>
@@ -4598,6 +4696,7 @@
           <a:lstStyle/>
           <a:p>
             <a:pPr algn="ctr"/>
+            <a:endParaRPr/>
           </a:p>
         </p:txBody>
       </p:sp>
@@ -4675,197 +4774,40 @@
           <a:lstStyle/>
           <a:p>
             <a:pPr algn="ctr"/>
-          </a:p>
-        </p:txBody>
-      </p:sp>
-      <p:sp>
-        <p:nvSpPr>
-          <p:cNvPr id="5" name="Rectangle 4"/>
-          <p:cNvSpPr/>
+            <a:endParaRPr/>
+          </a:p>
+        </p:txBody>
+      </p:sp>
+      <p:pic>
+        <p:nvPicPr>
+          <p:cNvPr id="11" name="Imagen 10">
+            <a:extLst>
+              <a:ext uri="{FF2B5EF4-FFF2-40B4-BE49-F238E27FC236}">
+                <a16:creationId xmlns:a16="http://schemas.microsoft.com/office/drawing/2014/main" id="{9BE2791D-3832-45CD-6DA5-D49D2B377D4A}"/>
+              </a:ext>
+            </a:extLst>
+          </p:cNvPr>
+          <p:cNvPicPr>
+            <a:picLocks noChangeAspect="1"/>
+          </p:cNvPicPr>
           <p:nvPr/>
-        </p:nvSpPr>
-        <p:spPr>
-          <a:xfrm>
-            <a:off x="1371600" y="1371600"/>
-            <a:ext cx="9418320" cy="4114800"/>
+        </p:nvPicPr>
+        <p:blipFill>
+          <a:blip r:embed="rId2"/>
+          <a:stretch>
+            <a:fillRect/>
+          </a:stretch>
+        </p:blipFill>
+        <p:spPr>
+          <a:xfrm>
+            <a:off x="4100456" y="1124712"/>
+            <a:ext cx="4359731" cy="5549870"/>
           </a:xfrm>
           <a:prstGeom prst="rect">
             <a:avLst/>
           </a:prstGeom>
-          <a:solidFill>
-            <a:srgbClr val="F2F2F2"/>
-          </a:solidFill>
-          <a:ln>
-            <a:noFill/>
-          </a:ln>
-        </p:spPr>
-        <p:style>
-          <a:lnRef idx="1">
-            <a:schemeClr val="accent1"/>
-          </a:lnRef>
-          <a:fillRef idx="3">
-            <a:schemeClr val="accent1"/>
-          </a:fillRef>
-          <a:effectRef idx="2">
-            <a:schemeClr val="accent1"/>
-          </a:effectRef>
-          <a:fontRef idx="minor">
-            <a:schemeClr val="lt1"/>
-          </a:fontRef>
-        </p:style>
-        <p:txBody>
-          <a:bodyPr rtlCol="0" anchor="ctr"/>
-          <a:lstStyle/>
-          <a:p>
-            <a:pPr algn="ctr"/>
-          </a:p>
-        </p:txBody>
-      </p:sp>
-      <p:sp>
-        <p:nvSpPr>
-          <p:cNvPr id="6" name="TextBox 5"/>
-          <p:cNvSpPr txBox="1"/>
-          <p:nvPr/>
-        </p:nvSpPr>
-        <p:spPr>
-          <a:xfrm>
-            <a:off x="1828800" y="2286000"/>
-            <a:ext cx="8503920" cy="1371600"/>
-          </a:xfrm>
-          <a:prstGeom prst="rect">
-            <a:avLst/>
-          </a:prstGeom>
-          <a:noFill/>
-        </p:spPr>
-        <p:txBody>
-          <a:bodyPr wrap="square"/>
-          <a:lstStyle/>
-          <a:p>
-            <a:pPr algn="ctr">
-              <a:defRPr sz="2400" b="0">
-                <a:solidFill>
-                  <a:srgbClr val="999999"/>
-                </a:solidFill>
-                <a:latin typeface="Calibri"/>
-              </a:defRPr>
-            </a:pPr>
-            <a:r>
-              <a:t>[Diagrama de arbol de decision con preguntas si/no que llevan a 'Usa blockchain' o 'Usa base de datos']</a:t>
-            </a:r>
-          </a:p>
-        </p:txBody>
-      </p:sp>
-      <p:sp>
-        <p:nvSpPr>
-          <p:cNvPr id="7" name="Rectangle 6"/>
-          <p:cNvSpPr/>
-          <p:nvPr/>
-        </p:nvSpPr>
-        <p:spPr>
-          <a:xfrm>
-            <a:off x="1371600" y="3840480"/>
-            <a:ext cx="9418320" cy="320040"/>
-          </a:xfrm>
-          <a:prstGeom prst="rect">
-            <a:avLst/>
-          </a:prstGeom>
-          <a:solidFill>
-            <a:srgbClr val="7C3AED"/>
-          </a:solidFill>
-          <a:ln>
-            <a:noFill/>
-          </a:ln>
-        </p:spPr>
-        <p:style>
-          <a:lnRef idx="1">
-            <a:schemeClr val="accent1"/>
-          </a:lnRef>
-          <a:fillRef idx="3">
-            <a:schemeClr val="accent1"/>
-          </a:fillRef>
-          <a:effectRef idx="2">
-            <a:schemeClr val="accent1"/>
-          </a:effectRef>
-          <a:fontRef idx="minor">
-            <a:schemeClr val="lt1"/>
-          </a:fontRef>
-        </p:style>
-        <p:txBody>
-          <a:bodyPr rtlCol="0" anchor="ctr"/>
-          <a:lstStyle/>
-          <a:p>
-            <a:pPr algn="ctr"/>
-          </a:p>
-        </p:txBody>
-      </p:sp>
-      <p:sp>
-        <p:nvSpPr>
-          <p:cNvPr id="8" name="TextBox 7"/>
-          <p:cNvSpPr txBox="1"/>
-          <p:nvPr/>
-        </p:nvSpPr>
-        <p:spPr>
-          <a:xfrm>
-            <a:off x="1371600" y="3840480"/>
-            <a:ext cx="9418320" cy="320040"/>
-          </a:xfrm>
-          <a:prstGeom prst="rect">
-            <a:avLst/>
-          </a:prstGeom>
-          <a:noFill/>
-        </p:spPr>
-        <p:txBody>
-          <a:bodyPr wrap="square"/>
-          <a:lstStyle/>
-          <a:p>
-            <a:pPr algn="ctr">
-              <a:defRPr sz="1300" b="1">
-                <a:solidFill>
-                  <a:srgbClr val="FFFFFF"/>
-                </a:solidFill>
-                <a:latin typeface="Calibri"/>
-              </a:defRPr>
-            </a:pPr>
-            <a:r>
-              <a:t>Prompt para IA generativa:</a:t>
-            </a:r>
-          </a:p>
-        </p:txBody>
-      </p:sp>
-      <p:sp>
-        <p:nvSpPr>
-          <p:cNvPr id="9" name="TextBox 8"/>
-          <p:cNvSpPr txBox="1"/>
-          <p:nvPr/>
-        </p:nvSpPr>
-        <p:spPr>
-          <a:xfrm>
-            <a:off x="1645920" y="4297680"/>
-            <a:ext cx="8869680" cy="914400"/>
-          </a:xfrm>
-          <a:prstGeom prst="rect">
-            <a:avLst/>
-          </a:prstGeom>
-          <a:noFill/>
-        </p:spPr>
-        <p:txBody>
-          <a:bodyPr wrap="square"/>
-          <a:lstStyle/>
-          <a:p>
-            <a:pPr algn="l">
-              <a:defRPr sz="1400" b="0">
-                <a:solidFill>
-                  <a:srgbClr val="7C3AED"/>
-                </a:solidFill>
-                <a:latin typeface="Consolas"/>
-              </a:defRPr>
-            </a:pPr>
-            <a:r>
-              <a:t>Decision tree flowchart: starting question 'Multiple parties that don't trust each other?' branching YES/NO through questions about shared data, immutability, verifiable rules, and neutral ownership. YES path leads to 'Consider blockchain', NO paths lead to 'Use a database'. Clean flat design, teal for YES paths, red for NO paths.</a:t>
-            </a:r>
-          </a:p>
-        </p:txBody>
-      </p:sp>
+        </p:spPr>
+      </p:pic>
     </p:spTree>
   </p:cSld>
   <p:clrMapOvr>
@@ -4875,7 +4817,7 @@
 </file>
 
 <file path=ppt/slides/slide14.xml><?xml version="1.0" encoding="utf-8"?>
-<p:sld xmlns:a="http://schemas.openxmlformats.org/drawingml/2006/main" xmlns:p="http://schemas.openxmlformats.org/presentationml/2006/main" xmlns:r="http://schemas.openxmlformats.org/officeDocument/2006/relationships">
+<p:sld xmlns:a="http://schemas.openxmlformats.org/drawingml/2006/main" xmlns:r="http://schemas.openxmlformats.org/officeDocument/2006/relationships" xmlns:p="http://schemas.openxmlformats.org/presentationml/2006/main">
   <p:cSld>
     <p:spTree>
       <p:nvGrpSpPr>
@@ -4883,7 +4825,418 @@
         <p:cNvGrpSpPr/>
         <p:nvPr/>
       </p:nvGrpSpPr>
-      <p:grpSpPr/>
+      <p:grpSpPr>
+        <a:xfrm>
+          <a:off x="0" y="0"/>
+          <a:ext cx="0" cy="0"/>
+          <a:chOff x="0" y="0"/>
+          <a:chExt cx="0" cy="0"/>
+        </a:xfrm>
+      </p:grpSpPr>
+      <p:sp>
+        <p:nvSpPr>
+          <p:cNvPr id="2" name="Rectangle 1"/>
+          <p:cNvSpPr/>
+          <p:nvPr/>
+        </p:nvSpPr>
+        <p:spPr>
+          <a:xfrm>
+            <a:off x="0" y="0"/>
+            <a:ext cx="12188952" cy="73152"/>
+          </a:xfrm>
+          <a:prstGeom prst="rect">
+            <a:avLst/>
+          </a:prstGeom>
+          <a:solidFill>
+            <a:srgbClr val="B45D09"/>
+          </a:solidFill>
+          <a:ln>
+            <a:noFill/>
+          </a:ln>
+        </p:spPr>
+        <p:style>
+          <a:lnRef idx="1">
+            <a:schemeClr val="accent1"/>
+          </a:lnRef>
+          <a:fillRef idx="3">
+            <a:schemeClr val="accent1"/>
+          </a:fillRef>
+          <a:effectRef idx="2">
+            <a:schemeClr val="accent1"/>
+          </a:effectRef>
+          <a:fontRef idx="minor">
+            <a:schemeClr val="lt1"/>
+          </a:fontRef>
+        </p:style>
+        <p:txBody>
+          <a:bodyPr rtlCol="0" anchor="ctr"/>
+          <a:lstStyle/>
+          <a:p>
+            <a:pPr algn="ctr"/>
+            <a:endParaRPr/>
+          </a:p>
+        </p:txBody>
+      </p:sp>
+      <p:sp>
+        <p:nvSpPr>
+          <p:cNvPr id="3" name="Rectangle 2"/>
+          <p:cNvSpPr/>
+          <p:nvPr/>
+        </p:nvSpPr>
+        <p:spPr>
+          <a:xfrm>
+            <a:off x="457200" y="274320"/>
+            <a:ext cx="3200400" cy="457200"/>
+          </a:xfrm>
+          <a:prstGeom prst="rect">
+            <a:avLst/>
+          </a:prstGeom>
+          <a:solidFill>
+            <a:srgbClr val="B45D09"/>
+          </a:solidFill>
+          <a:ln>
+            <a:noFill/>
+          </a:ln>
+        </p:spPr>
+        <p:style>
+          <a:lnRef idx="1">
+            <a:schemeClr val="accent1"/>
+          </a:lnRef>
+          <a:fillRef idx="3">
+            <a:schemeClr val="accent1"/>
+          </a:fillRef>
+          <a:effectRef idx="2">
+            <a:schemeClr val="accent1"/>
+          </a:effectRef>
+          <a:fontRef idx="minor">
+            <a:schemeClr val="lt1"/>
+          </a:fontRef>
+        </p:style>
+        <p:txBody>
+          <a:bodyPr rtlCol="0" anchor="ctr"/>
+          <a:lstStyle/>
+          <a:p>
+            <a:pPr algn="ctr"/>
+            <a:endParaRPr/>
+          </a:p>
+        </p:txBody>
+      </p:sp>
+      <p:sp>
+        <p:nvSpPr>
+          <p:cNvPr id="4" name="TextBox 3"/>
+          <p:cNvSpPr txBox="1"/>
+          <p:nvPr/>
+        </p:nvSpPr>
+        <p:spPr>
+          <a:xfrm>
+            <a:off x="457200" y="274320"/>
+            <a:ext cx="3200400" cy="457200"/>
+          </a:xfrm>
+          <a:prstGeom prst="rect">
+            <a:avLst/>
+          </a:prstGeom>
+          <a:noFill/>
+        </p:spPr>
+        <p:txBody>
+          <a:bodyPr wrap="square"/>
+          <a:lstStyle/>
+          <a:p>
+            <a:pPr algn="ctr">
+              <a:defRPr sz="1800" b="1">
+                <a:solidFill>
+                  <a:srgbClr val="FFFFFF"/>
+                </a:solidFill>
+                <a:latin typeface="Calibri"/>
+              </a:defRPr>
+            </a:pPr>
+            <a:r>
+              <a:t>TREASURE HUNT</a:t>
+            </a:r>
+          </a:p>
+        </p:txBody>
+      </p:sp>
+      <p:sp>
+        <p:nvSpPr>
+          <p:cNvPr id="5" name="TextBox 4"/>
+          <p:cNvSpPr txBox="1"/>
+          <p:nvPr/>
+        </p:nvSpPr>
+        <p:spPr>
+          <a:xfrm>
+            <a:off x="3931920" y="228600"/>
+            <a:ext cx="7772400" cy="731520"/>
+          </a:xfrm>
+          <a:prstGeom prst="rect">
+            <a:avLst/>
+          </a:prstGeom>
+          <a:noFill/>
+        </p:spPr>
+        <p:txBody>
+          <a:bodyPr wrap="square"/>
+          <a:lstStyle/>
+          <a:p>
+            <a:pPr algn="l">
+              <a:defRPr sz="2800" b="1">
+                <a:solidFill>
+                  <a:srgbClr val="333333"/>
+                </a:solidFill>
+                <a:latin typeface="Calibri"/>
+              </a:defRPr>
+            </a:pPr>
+            <a:r>
+              <a:t>El primer proyecto blockchain enterprise</a:t>
+            </a:r>
+          </a:p>
+        </p:txBody>
+      </p:sp>
+      <p:sp>
+        <p:nvSpPr>
+          <p:cNvPr id="6" name="Rectangle 5"/>
+          <p:cNvSpPr/>
+          <p:nvPr/>
+        </p:nvSpPr>
+        <p:spPr>
+          <a:xfrm>
+            <a:off x="457200" y="1051560"/>
+            <a:ext cx="10972800" cy="27432"/>
+          </a:xfrm>
+          <a:prstGeom prst="rect">
+            <a:avLst/>
+          </a:prstGeom>
+          <a:solidFill>
+            <a:srgbClr val="B45D09"/>
+          </a:solidFill>
+          <a:ln>
+            <a:noFill/>
+          </a:ln>
+        </p:spPr>
+        <p:style>
+          <a:lnRef idx="1">
+            <a:schemeClr val="accent1"/>
+          </a:lnRef>
+          <a:fillRef idx="3">
+            <a:schemeClr val="accent1"/>
+          </a:fillRef>
+          <a:effectRef idx="2">
+            <a:schemeClr val="accent1"/>
+          </a:effectRef>
+          <a:fontRef idx="minor">
+            <a:schemeClr val="lt1"/>
+          </a:fontRef>
+        </p:style>
+        <p:txBody>
+          <a:bodyPr rtlCol="0" anchor="ctr"/>
+          <a:lstStyle/>
+          <a:p>
+            <a:pPr algn="ctr"/>
+            <a:endParaRPr/>
+          </a:p>
+        </p:txBody>
+      </p:sp>
+      <p:sp>
+        <p:nvSpPr>
+          <p:cNvPr id="7" name="TextBox 6"/>
+          <p:cNvSpPr txBox="1"/>
+          <p:nvPr/>
+        </p:nvSpPr>
+        <p:spPr>
+          <a:xfrm>
+            <a:off x="640080" y="1371600"/>
+            <a:ext cx="10515600" cy="5029200"/>
+          </a:xfrm>
+          <a:prstGeom prst="rect">
+            <a:avLst/>
+          </a:prstGeom>
+          <a:noFill/>
+        </p:spPr>
+        <p:txBody>
+          <a:bodyPr wrap="square">
+            <a:spAutoFit/>
+          </a:bodyPr>
+          <a:lstStyle/>
+          <a:p>
+            <a:pPr>
+              <a:spcAft>
+                <a:spcPts val="1000"/>
+              </a:spcAft>
+              <a:defRPr sz="2000">
+                <a:solidFill>
+                  <a:srgbClr val="333333"/>
+                </a:solidFill>
+                <a:latin typeface="Calibri"/>
+              </a:defRPr>
+            </a:pPr>
+            <a:r>
+              <a:t>Antes de Fabric, antes de Corda, antes de los consorcios...</a:t>
+            </a:r>
+          </a:p>
+          <a:p>
+            <a:pPr>
+              <a:spcAft>
+                <a:spcPts val="1000"/>
+              </a:spcAft>
+              <a:defRPr sz="2000">
+                <a:solidFill>
+                  <a:srgbClr val="333333"/>
+                </a:solidFill>
+                <a:latin typeface="Calibri"/>
+              </a:defRPr>
+            </a:pPr>
+            <a:r>
+              <a:t>hubo un proyecto que demostro que blockchain podia usarse en empresas.</a:t>
+            </a:r>
+          </a:p>
+          <a:p>
+            <a:pPr>
+              <a:spcAft>
+                <a:spcPts val="1000"/>
+              </a:spcAft>
+              <a:defRPr sz="2000">
+                <a:solidFill>
+                  <a:srgbClr val="333333"/>
+                </a:solidFill>
+                <a:latin typeface="Calibri"/>
+              </a:defRPr>
+            </a:pPr>
+            <a:endParaRPr/>
+          </a:p>
+          <a:p>
+            <a:pPr>
+              <a:spcAft>
+                <a:spcPts val="1000"/>
+              </a:spcAft>
+              <a:defRPr sz="2000">
+                <a:solidFill>
+                  <a:srgbClr val="333333"/>
+                </a:solidFill>
+                <a:latin typeface="Calibri"/>
+              </a:defRPr>
+            </a:pPr>
+            <a:r>
+              <a:t>Mision: Investigar:</a:t>
+            </a:r>
+          </a:p>
+          <a:p>
+            <a:pPr>
+              <a:spcAft>
+                <a:spcPts val="1000"/>
+              </a:spcAft>
+              <a:defRPr sz="2000">
+                <a:solidFill>
+                  <a:srgbClr val="333333"/>
+                </a:solidFill>
+                <a:latin typeface="Calibri"/>
+              </a:defRPr>
+            </a:pPr>
+            <a:r>
+              <a:t>  1. ¿Que proyecto se considera el primero en usar blockchain en enterprise?</a:t>
+            </a:r>
+          </a:p>
+          <a:p>
+            <a:pPr>
+              <a:spcAft>
+                <a:spcPts val="1000"/>
+              </a:spcAft>
+              <a:defRPr sz="2000">
+                <a:solidFill>
+                  <a:srgbClr val="333333"/>
+                </a:solidFill>
+                <a:latin typeface="Calibri"/>
+              </a:defRPr>
+            </a:pPr>
+            <a:r>
+              <a:t>     Pista: fue en el sector financiero, en 2015, y no usaba Ethereum.</a:t>
+            </a:r>
+          </a:p>
+          <a:p>
+            <a:pPr>
+              <a:spcAft>
+                <a:spcPts val="1000"/>
+              </a:spcAft>
+              <a:defRPr sz="2000">
+                <a:solidFill>
+                  <a:srgbClr val="333333"/>
+                </a:solidFill>
+                <a:latin typeface="Calibri"/>
+              </a:defRPr>
+            </a:pPr>
+            <a:r>
+              <a:t>  2. ¿Que empresa lo impulso?</a:t>
+            </a:r>
+          </a:p>
+          <a:p>
+            <a:pPr>
+              <a:spcAft>
+                <a:spcPts val="1000"/>
+              </a:spcAft>
+              <a:defRPr sz="2000">
+                <a:solidFill>
+                  <a:srgbClr val="333333"/>
+                </a:solidFill>
+                <a:latin typeface="Calibri"/>
+              </a:defRPr>
+            </a:pPr>
+            <a:r>
+              <a:t>  3. ¿En que se convirtio ese proyecto despues?</a:t>
+            </a:r>
+          </a:p>
+          <a:p>
+            <a:pPr>
+              <a:spcAft>
+                <a:spcPts val="1000"/>
+              </a:spcAft>
+              <a:defRPr sz="2000">
+                <a:solidFill>
+                  <a:srgbClr val="333333"/>
+                </a:solidFill>
+                <a:latin typeface="Calibri"/>
+              </a:defRPr>
+            </a:pPr>
+            <a:endParaRPr/>
+          </a:p>
+          <a:p>
+            <a:pPr>
+              <a:spcAft>
+                <a:spcPts val="1000"/>
+              </a:spcAft>
+              <a:defRPr sz="2000">
+                <a:solidFill>
+                  <a:srgbClr val="333333"/>
+                </a:solidFill>
+                <a:latin typeface="Calibri"/>
+              </a:defRPr>
+            </a:pPr>
+            <a:r>
+              <a:t>Tiempo: 10 minutos.</a:t>
+            </a:r>
+          </a:p>
+        </p:txBody>
+      </p:sp>
+    </p:spTree>
+  </p:cSld>
+  <p:clrMapOvr>
+    <a:masterClrMapping/>
+  </p:clrMapOvr>
+</p:sld>
+</file>
+
+<file path=ppt/slides/slide15.xml><?xml version="1.0" encoding="utf-8"?>
+<p:sld xmlns:a="http://schemas.openxmlformats.org/drawingml/2006/main" xmlns:r="http://schemas.openxmlformats.org/officeDocument/2006/relationships" xmlns:p="http://schemas.openxmlformats.org/presentationml/2006/main">
+  <p:cSld>
+    <p:spTree>
+      <p:nvGrpSpPr>
+        <p:cNvPr id="1" name=""/>
+        <p:cNvGrpSpPr/>
+        <p:nvPr/>
+      </p:nvGrpSpPr>
+      <p:grpSpPr>
+        <a:xfrm>
+          <a:off x="0" y="0"/>
+          <a:ext cx="0" cy="0"/>
+          <a:chOff x="0" y="0"/>
+          <a:chExt cx="0" cy="0"/>
+        </a:xfrm>
+      </p:grpSpPr>
       <p:sp>
         <p:nvSpPr>
           <p:cNvPr id="2" name="Rectangle 1"/>
@@ -4924,6 +5277,7 @@
           <a:lstStyle/>
           <a:p>
             <a:pPr algn="ctr"/>
+            <a:endParaRPr/>
           </a:p>
         </p:txBody>
       </p:sp>
@@ -4967,6 +5321,7 @@
           <a:lstStyle/>
           <a:p>
             <a:pPr algn="ctr"/>
+            <a:endParaRPr/>
           </a:p>
         </p:txBody>
       </p:sp>
@@ -5078,6 +5433,7 @@
           <a:lstStyle/>
           <a:p>
             <a:pPr algn="ctr"/>
+            <a:endParaRPr/>
           </a:p>
         </p:txBody>
       </p:sp>
@@ -5130,6 +5486,7 @@
                 <a:latin typeface="Calibri"/>
               </a:defRPr>
             </a:pPr>
+            <a:endParaRPr/>
           </a:p>
           <a:p>
             <a:pPr>
@@ -5225,398 +5582,6 @@
             </a:pPr>
             <a:r>
               <a:t>6. Un consorcio de 50 productores quiere certificar el origen de sus productos</a:t>
-            </a:r>
-          </a:p>
-        </p:txBody>
-      </p:sp>
-    </p:spTree>
-  </p:cSld>
-  <p:clrMapOvr>
-    <a:masterClrMapping/>
-  </p:clrMapOvr>
-</p:sld>
-</file>
-
-<file path=ppt/slides/slide15.xml><?xml version="1.0" encoding="utf-8"?>
-<p:sld xmlns:a="http://schemas.openxmlformats.org/drawingml/2006/main" xmlns:p="http://schemas.openxmlformats.org/presentationml/2006/main" xmlns:r="http://schemas.openxmlformats.org/officeDocument/2006/relationships">
-  <p:cSld>
-    <p:spTree>
-      <p:nvGrpSpPr>
-        <p:cNvPr id="1" name=""/>
-        <p:cNvGrpSpPr/>
-        <p:nvPr/>
-      </p:nvGrpSpPr>
-      <p:grpSpPr/>
-      <p:sp>
-        <p:nvSpPr>
-          <p:cNvPr id="2" name="Rectangle 1"/>
-          <p:cNvSpPr/>
-          <p:nvPr/>
-        </p:nvSpPr>
-        <p:spPr>
-          <a:xfrm>
-            <a:off x="0" y="0"/>
-            <a:ext cx="12188952" cy="73152"/>
-          </a:xfrm>
-          <a:prstGeom prst="rect">
-            <a:avLst/>
-          </a:prstGeom>
-          <a:solidFill>
-            <a:srgbClr val="B45D09"/>
-          </a:solidFill>
-          <a:ln>
-            <a:noFill/>
-          </a:ln>
-        </p:spPr>
-        <p:style>
-          <a:lnRef idx="1">
-            <a:schemeClr val="accent1"/>
-          </a:lnRef>
-          <a:fillRef idx="3">
-            <a:schemeClr val="accent1"/>
-          </a:fillRef>
-          <a:effectRef idx="2">
-            <a:schemeClr val="accent1"/>
-          </a:effectRef>
-          <a:fontRef idx="minor">
-            <a:schemeClr val="lt1"/>
-          </a:fontRef>
-        </p:style>
-        <p:txBody>
-          <a:bodyPr rtlCol="0" anchor="ctr"/>
-          <a:lstStyle/>
-          <a:p>
-            <a:pPr algn="ctr"/>
-          </a:p>
-        </p:txBody>
-      </p:sp>
-      <p:sp>
-        <p:nvSpPr>
-          <p:cNvPr id="3" name="Rectangle 2"/>
-          <p:cNvSpPr/>
-          <p:nvPr/>
-        </p:nvSpPr>
-        <p:spPr>
-          <a:xfrm>
-            <a:off x="457200" y="274320"/>
-            <a:ext cx="3200400" cy="457200"/>
-          </a:xfrm>
-          <a:prstGeom prst="rect">
-            <a:avLst/>
-          </a:prstGeom>
-          <a:solidFill>
-            <a:srgbClr val="B45D09"/>
-          </a:solidFill>
-          <a:ln>
-            <a:noFill/>
-          </a:ln>
-        </p:spPr>
-        <p:style>
-          <a:lnRef idx="1">
-            <a:schemeClr val="accent1"/>
-          </a:lnRef>
-          <a:fillRef idx="3">
-            <a:schemeClr val="accent1"/>
-          </a:fillRef>
-          <a:effectRef idx="2">
-            <a:schemeClr val="accent1"/>
-          </a:effectRef>
-          <a:fontRef idx="minor">
-            <a:schemeClr val="lt1"/>
-          </a:fontRef>
-        </p:style>
-        <p:txBody>
-          <a:bodyPr rtlCol="0" anchor="ctr"/>
-          <a:lstStyle/>
-          <a:p>
-            <a:pPr algn="ctr"/>
-          </a:p>
-        </p:txBody>
-      </p:sp>
-      <p:sp>
-        <p:nvSpPr>
-          <p:cNvPr id="4" name="TextBox 3"/>
-          <p:cNvSpPr txBox="1"/>
-          <p:nvPr/>
-        </p:nvSpPr>
-        <p:spPr>
-          <a:xfrm>
-            <a:off x="457200" y="274320"/>
-            <a:ext cx="3200400" cy="457200"/>
-          </a:xfrm>
-          <a:prstGeom prst="rect">
-            <a:avLst/>
-          </a:prstGeom>
-          <a:noFill/>
-        </p:spPr>
-        <p:txBody>
-          <a:bodyPr wrap="square"/>
-          <a:lstStyle/>
-          <a:p>
-            <a:pPr algn="ctr">
-              <a:defRPr sz="1800" b="1">
-                <a:solidFill>
-                  <a:srgbClr val="FFFFFF"/>
-                </a:solidFill>
-                <a:latin typeface="Calibri"/>
-              </a:defRPr>
-            </a:pPr>
-            <a:r>
-              <a:t>TREASURE HUNT</a:t>
-            </a:r>
-          </a:p>
-        </p:txBody>
-      </p:sp>
-      <p:sp>
-        <p:nvSpPr>
-          <p:cNvPr id="5" name="TextBox 4"/>
-          <p:cNvSpPr txBox="1"/>
-          <p:nvPr/>
-        </p:nvSpPr>
-        <p:spPr>
-          <a:xfrm>
-            <a:off x="3931920" y="228600"/>
-            <a:ext cx="7772400" cy="731520"/>
-          </a:xfrm>
-          <a:prstGeom prst="rect">
-            <a:avLst/>
-          </a:prstGeom>
-          <a:noFill/>
-        </p:spPr>
-        <p:txBody>
-          <a:bodyPr wrap="square"/>
-          <a:lstStyle/>
-          <a:p>
-            <a:pPr algn="l">
-              <a:defRPr sz="2800" b="1">
-                <a:solidFill>
-                  <a:srgbClr val="333333"/>
-                </a:solidFill>
-                <a:latin typeface="Calibri"/>
-              </a:defRPr>
-            </a:pPr>
-            <a:r>
-              <a:t>El primer proyecto blockchain enterprise</a:t>
-            </a:r>
-          </a:p>
-        </p:txBody>
-      </p:sp>
-      <p:sp>
-        <p:nvSpPr>
-          <p:cNvPr id="6" name="Rectangle 5"/>
-          <p:cNvSpPr/>
-          <p:nvPr/>
-        </p:nvSpPr>
-        <p:spPr>
-          <a:xfrm>
-            <a:off x="457200" y="1051560"/>
-            <a:ext cx="10972800" cy="27432"/>
-          </a:xfrm>
-          <a:prstGeom prst="rect">
-            <a:avLst/>
-          </a:prstGeom>
-          <a:solidFill>
-            <a:srgbClr val="B45D09"/>
-          </a:solidFill>
-          <a:ln>
-            <a:noFill/>
-          </a:ln>
-        </p:spPr>
-        <p:style>
-          <a:lnRef idx="1">
-            <a:schemeClr val="accent1"/>
-          </a:lnRef>
-          <a:fillRef idx="3">
-            <a:schemeClr val="accent1"/>
-          </a:fillRef>
-          <a:effectRef idx="2">
-            <a:schemeClr val="accent1"/>
-          </a:effectRef>
-          <a:fontRef idx="minor">
-            <a:schemeClr val="lt1"/>
-          </a:fontRef>
-        </p:style>
-        <p:txBody>
-          <a:bodyPr rtlCol="0" anchor="ctr"/>
-          <a:lstStyle/>
-          <a:p>
-            <a:pPr algn="ctr"/>
-          </a:p>
-        </p:txBody>
-      </p:sp>
-      <p:sp>
-        <p:nvSpPr>
-          <p:cNvPr id="7" name="TextBox 6"/>
-          <p:cNvSpPr txBox="1"/>
-          <p:nvPr/>
-        </p:nvSpPr>
-        <p:spPr>
-          <a:xfrm>
-            <a:off x="640080" y="1371600"/>
-            <a:ext cx="10515600" cy="5029200"/>
-          </a:xfrm>
-          <a:prstGeom prst="rect">
-            <a:avLst/>
-          </a:prstGeom>
-          <a:noFill/>
-        </p:spPr>
-        <p:txBody>
-          <a:bodyPr wrap="square">
-            <a:spAutoFit/>
-          </a:bodyPr>
-          <a:lstStyle/>
-          <a:p>
-            <a:pPr>
-              <a:spcAft>
-                <a:spcPts val="1000"/>
-              </a:spcAft>
-              <a:defRPr sz="2000">
-                <a:solidFill>
-                  <a:srgbClr val="333333"/>
-                </a:solidFill>
-                <a:latin typeface="Calibri"/>
-              </a:defRPr>
-            </a:pPr>
-            <a:r>
-              <a:t>Antes de Fabric, antes de Corda, antes de los consorcios...</a:t>
-            </a:r>
-          </a:p>
-          <a:p>
-            <a:pPr>
-              <a:spcAft>
-                <a:spcPts val="1000"/>
-              </a:spcAft>
-              <a:defRPr sz="2000">
-                <a:solidFill>
-                  <a:srgbClr val="333333"/>
-                </a:solidFill>
-                <a:latin typeface="Calibri"/>
-              </a:defRPr>
-            </a:pPr>
-            <a:r>
-              <a:t>hubo un proyecto que demostro que blockchain podia usarse en empresas.</a:t>
-            </a:r>
-          </a:p>
-          <a:p>
-            <a:pPr>
-              <a:spcAft>
-                <a:spcPts val="1000"/>
-              </a:spcAft>
-              <a:defRPr sz="2000">
-                <a:solidFill>
-                  <a:srgbClr val="333333"/>
-                </a:solidFill>
-                <a:latin typeface="Calibri"/>
-              </a:defRPr>
-            </a:pPr>
-          </a:p>
-          <a:p>
-            <a:pPr>
-              <a:spcAft>
-                <a:spcPts val="1000"/>
-              </a:spcAft>
-              <a:defRPr sz="2000">
-                <a:solidFill>
-                  <a:srgbClr val="333333"/>
-                </a:solidFill>
-                <a:latin typeface="Calibri"/>
-              </a:defRPr>
-            </a:pPr>
-            <a:r>
-              <a:t>Mision: Investigar:</a:t>
-            </a:r>
-          </a:p>
-          <a:p>
-            <a:pPr>
-              <a:spcAft>
-                <a:spcPts val="1000"/>
-              </a:spcAft>
-              <a:defRPr sz="2000">
-                <a:solidFill>
-                  <a:srgbClr val="333333"/>
-                </a:solidFill>
-                <a:latin typeface="Calibri"/>
-              </a:defRPr>
-            </a:pPr>
-            <a:r>
-              <a:t>  1. ¿Que proyecto se considera el primero en usar blockchain en enterprise?</a:t>
-            </a:r>
-          </a:p>
-          <a:p>
-            <a:pPr>
-              <a:spcAft>
-                <a:spcPts val="1000"/>
-              </a:spcAft>
-              <a:defRPr sz="2000">
-                <a:solidFill>
-                  <a:srgbClr val="333333"/>
-                </a:solidFill>
-                <a:latin typeface="Calibri"/>
-              </a:defRPr>
-            </a:pPr>
-            <a:r>
-              <a:t>     Pista: fue en el sector financiero, en 2015, y no usaba Ethereum.</a:t>
-            </a:r>
-          </a:p>
-          <a:p>
-            <a:pPr>
-              <a:spcAft>
-                <a:spcPts val="1000"/>
-              </a:spcAft>
-              <a:defRPr sz="2000">
-                <a:solidFill>
-                  <a:srgbClr val="333333"/>
-                </a:solidFill>
-                <a:latin typeface="Calibri"/>
-              </a:defRPr>
-            </a:pPr>
-            <a:r>
-              <a:t>  2. ¿Que empresa lo impulso?</a:t>
-            </a:r>
-          </a:p>
-          <a:p>
-            <a:pPr>
-              <a:spcAft>
-                <a:spcPts val="1000"/>
-              </a:spcAft>
-              <a:defRPr sz="2000">
-                <a:solidFill>
-                  <a:srgbClr val="333333"/>
-                </a:solidFill>
-                <a:latin typeface="Calibri"/>
-              </a:defRPr>
-            </a:pPr>
-            <a:r>
-              <a:t>  3. ¿En que se convirtio ese proyecto despues?</a:t>
-            </a:r>
-          </a:p>
-          <a:p>
-            <a:pPr>
-              <a:spcAft>
-                <a:spcPts val="1000"/>
-              </a:spcAft>
-              <a:defRPr sz="2000">
-                <a:solidFill>
-                  <a:srgbClr val="333333"/>
-                </a:solidFill>
-                <a:latin typeface="Calibri"/>
-              </a:defRPr>
-            </a:pPr>
-          </a:p>
-          <a:p>
-            <a:pPr>
-              <a:spcAft>
-                <a:spcPts val="1000"/>
-              </a:spcAft>
-              <a:defRPr sz="2000">
-                <a:solidFill>
-                  <a:srgbClr val="333333"/>
-                </a:solidFill>
-                <a:latin typeface="Calibri"/>
-              </a:defRPr>
-            </a:pPr>
-            <a:r>
-              <a:t>Tiempo: 10 minutos.</a:t>
             </a:r>
           </a:p>
         </p:txBody>
@@ -5630,7 +5595,7 @@
 </file>
 
 <file path=ppt/slides/slide16.xml><?xml version="1.0" encoding="utf-8"?>
-<p:sld xmlns:a="http://schemas.openxmlformats.org/drawingml/2006/main" xmlns:p="http://schemas.openxmlformats.org/presentationml/2006/main" xmlns:r="http://schemas.openxmlformats.org/officeDocument/2006/relationships">
+<p:sld xmlns:a="http://schemas.openxmlformats.org/drawingml/2006/main" xmlns:r="http://schemas.openxmlformats.org/officeDocument/2006/relationships" xmlns:p="http://schemas.openxmlformats.org/presentationml/2006/main">
   <p:cSld>
     <p:spTree>
       <p:nvGrpSpPr>
@@ -5638,7 +5603,14 @@
         <p:cNvGrpSpPr/>
         <p:nvPr/>
       </p:nvGrpSpPr>
-      <p:grpSpPr/>
+      <p:grpSpPr>
+        <a:xfrm>
+          <a:off x="0" y="0"/>
+          <a:ext cx="0" cy="0"/>
+          <a:chOff x="0" y="0"/>
+          <a:chExt cx="0" cy="0"/>
+        </a:xfrm>
+      </p:grpSpPr>
       <p:sp>
         <p:nvSpPr>
           <p:cNvPr id="2" name="Rectangle 1"/>
@@ -5679,6 +5651,7 @@
           <a:lstStyle/>
           <a:p>
             <a:pPr algn="ctr"/>
+            <a:endParaRPr/>
           </a:p>
         </p:txBody>
       </p:sp>
@@ -5756,6 +5729,7 @@
           <a:lstStyle/>
           <a:p>
             <a:pPr algn="ctr"/>
+            <a:endParaRPr/>
           </a:p>
         </p:txBody>
       </p:sp>
@@ -5870,8 +5844,8 @@
 </p:sld>
 </file>
 
-<file path=ppt/slides/slide2.xml><?xml version="1.0" encoding="utf-8"?>
-<p:sld xmlns:a="http://schemas.openxmlformats.org/drawingml/2006/main" xmlns:p="http://schemas.openxmlformats.org/presentationml/2006/main" xmlns:r="http://schemas.openxmlformats.org/officeDocument/2006/relationships">
+<file path=ppt/slides/slide17.xml><?xml version="1.0" encoding="utf-8"?>
+<p:sld xmlns:a="http://schemas.openxmlformats.org/drawingml/2006/main" xmlns:r="http://schemas.openxmlformats.org/officeDocument/2006/relationships" xmlns:p="http://schemas.openxmlformats.org/presentationml/2006/main">
   <p:cSld>
     <p:spTree>
       <p:nvGrpSpPr>
@@ -5879,7 +5853,14 @@
         <p:cNvGrpSpPr/>
         <p:nvPr/>
       </p:nvGrpSpPr>
-      <p:grpSpPr/>
+      <p:grpSpPr>
+        <a:xfrm>
+          <a:off x="0" y="0"/>
+          <a:ext cx="0" cy="0"/>
+          <a:chOff x="0" y="0"/>
+          <a:chExt cx="0" cy="0"/>
+        </a:xfrm>
+      </p:grpSpPr>
       <p:sp>
         <p:nvSpPr>
           <p:cNvPr id="2" name="Rectangle 1"/>
@@ -5889,7 +5870,7 @@
         <p:spPr>
           <a:xfrm>
             <a:off x="0" y="0"/>
-            <a:ext cx="12188952" cy="6858000"/>
+            <a:ext cx="12188952" cy="73152"/>
           </a:xfrm>
           <a:prstGeom prst="rect">
             <a:avLst/>
@@ -5920,6 +5901,1508 @@
           <a:lstStyle/>
           <a:p>
             <a:pPr algn="ctr"/>
+            <a:endParaRPr/>
+          </a:p>
+        </p:txBody>
+      </p:sp>
+      <p:sp>
+        <p:nvSpPr>
+          <p:cNvPr id="3" name="TextBox 2"/>
+          <p:cNvSpPr txBox="1"/>
+          <p:nvPr/>
+        </p:nvSpPr>
+        <p:spPr>
+          <a:xfrm>
+            <a:off x="457200" y="274320"/>
+            <a:ext cx="10972800" cy="731520"/>
+          </a:xfrm>
+          <a:prstGeom prst="rect">
+            <a:avLst/>
+          </a:prstGeom>
+          <a:noFill/>
+        </p:spPr>
+        <p:txBody>
+          <a:bodyPr wrap="square"/>
+          <a:lstStyle/>
+          <a:p>
+            <a:pPr algn="l">
+              <a:defRPr sz="3200" b="1">
+                <a:solidFill>
+                  <a:srgbClr val="22627E"/>
+                </a:solidFill>
+                <a:latin typeface="Calibri"/>
+              </a:defRPr>
+            </a:pPr>
+            <a:r>
+              <a:t>Respuestas al debate: ¿blockchain o BD?</a:t>
+            </a:r>
+          </a:p>
+        </p:txBody>
+      </p:sp>
+      <p:sp>
+        <p:nvSpPr>
+          <p:cNvPr id="4" name="Rectangle 3"/>
+          <p:cNvSpPr/>
+          <p:nvPr/>
+        </p:nvSpPr>
+        <p:spPr>
+          <a:xfrm>
+            <a:off x="457200" y="1051560"/>
+            <a:ext cx="10972800" cy="27432"/>
+          </a:xfrm>
+          <a:prstGeom prst="rect">
+            <a:avLst/>
+          </a:prstGeom>
+          <a:solidFill>
+            <a:srgbClr val="22627E"/>
+          </a:solidFill>
+          <a:ln>
+            <a:noFill/>
+          </a:ln>
+        </p:spPr>
+        <p:style>
+          <a:lnRef idx="1">
+            <a:schemeClr val="accent1"/>
+          </a:lnRef>
+          <a:fillRef idx="3">
+            <a:schemeClr val="accent1"/>
+          </a:fillRef>
+          <a:effectRef idx="2">
+            <a:schemeClr val="accent1"/>
+          </a:effectRef>
+          <a:fontRef idx="minor">
+            <a:schemeClr val="lt1"/>
+          </a:fontRef>
+        </p:style>
+        <p:txBody>
+          <a:bodyPr rtlCol="0" anchor="ctr"/>
+          <a:lstStyle/>
+          <a:p>
+            <a:pPr algn="ctr"/>
+            <a:endParaRPr/>
+          </a:p>
+        </p:txBody>
+      </p:sp>
+      <p:sp>
+        <p:nvSpPr>
+          <p:cNvPr id="5" name="TextBox 4"/>
+          <p:cNvSpPr txBox="1"/>
+          <p:nvPr/>
+        </p:nvSpPr>
+        <p:spPr>
+          <a:xfrm>
+            <a:off x="640080" y="1280160"/>
+            <a:ext cx="10515600" cy="5029200"/>
+          </a:xfrm>
+          <a:prstGeom prst="rect">
+            <a:avLst/>
+          </a:prstGeom>
+          <a:noFill/>
+        </p:spPr>
+        <p:txBody>
+          <a:bodyPr wrap="square">
+            <a:spAutoFit/>
+          </a:bodyPr>
+          <a:lstStyle/>
+          <a:p>
+            <a:pPr>
+              <a:spcAft>
+                <a:spcPts val="800"/>
+              </a:spcAft>
+              <a:defRPr sz="2000">
+                <a:solidFill>
+                  <a:srgbClr val="333333"/>
+                </a:solidFill>
+                <a:latin typeface="Calibri"/>
+              </a:defRPr>
+            </a:pPr>
+            <a:r>
+              <a:t>1. Hospital registra historiales de sus pacientes:</a:t>
+            </a:r>
+          </a:p>
+          <a:p>
+            <a:pPr lvl="1">
+              <a:spcAft>
+                <a:spcPts val="400"/>
+              </a:spcAft>
+              <a:defRPr sz="1700">
+                <a:solidFill>
+                  <a:srgbClr val="666666"/>
+                </a:solidFill>
+                <a:latin typeface="Calibri"/>
+              </a:defRPr>
+            </a:pPr>
+            <a:r>
+              <a:t>    BD tradicional. Un solo actor, sin necesidad de compartir. Blockchain seria over-engineering.</a:t>
+            </a:r>
+          </a:p>
+          <a:p>
+            <a:pPr>
+              <a:spcAft>
+                <a:spcPts val="800"/>
+              </a:spcAft>
+              <a:defRPr sz="2000">
+                <a:solidFill>
+                  <a:srgbClr val="333333"/>
+                </a:solidFill>
+                <a:latin typeface="Calibri"/>
+              </a:defRPr>
+            </a:pPr>
+            <a:r>
+              <a:t>2. Tres hospitales comparten historiales de pacientes compartidos:</a:t>
+            </a:r>
+          </a:p>
+          <a:p>
+            <a:pPr lvl="1">
+              <a:spcAft>
+                <a:spcPts val="400"/>
+              </a:spcAft>
+              <a:defRPr sz="1700">
+                <a:solidFill>
+                  <a:srgbClr val="666666"/>
+                </a:solidFill>
+                <a:latin typeface="Calibri"/>
+              </a:defRPr>
+            </a:pPr>
+            <a:r>
+              <a:t>    Blockchain. Multiples orgs, datos compartidos, trazabilidad necesaria.</a:t>
+            </a:r>
+          </a:p>
+          <a:p>
+            <a:pPr lvl="1">
+              <a:spcAft>
+                <a:spcPts val="400"/>
+              </a:spcAft>
+              <a:defRPr sz="1700">
+                <a:solidFill>
+                  <a:srgbClr val="666666"/>
+                </a:solidFill>
+                <a:latin typeface="Calibri"/>
+              </a:defRPr>
+            </a:pPr>
+            <a:r>
+              <a:t>    Requiere diseño con Private Data para proteger datos personales (GDPR).</a:t>
+            </a:r>
+          </a:p>
+          <a:p>
+            <a:pPr>
+              <a:spcAft>
+                <a:spcPts val="800"/>
+              </a:spcAft>
+              <a:defRPr sz="2000">
+                <a:solidFill>
+                  <a:srgbClr val="333333"/>
+                </a:solidFill>
+                <a:latin typeface="Calibri"/>
+              </a:defRPr>
+            </a:pPr>
+            <a:r>
+              <a:t>3. Banco registra sus transacciones internas:</a:t>
+            </a:r>
+          </a:p>
+          <a:p>
+            <a:pPr lvl="1">
+              <a:spcAft>
+                <a:spcPts val="400"/>
+              </a:spcAft>
+              <a:defRPr sz="1700">
+                <a:solidFill>
+                  <a:srgbClr val="666666"/>
+                </a:solidFill>
+                <a:latin typeface="Calibri"/>
+              </a:defRPr>
+            </a:pPr>
+            <a:r>
+              <a:t>    BD tradicional. Un solo actor; si necesita auditoria, append-only DB o WORM storage.</a:t>
+            </a:r>
+          </a:p>
+          <a:p>
+            <a:pPr>
+              <a:spcAft>
+                <a:spcPts val="800"/>
+              </a:spcAft>
+              <a:defRPr sz="2000">
+                <a:solidFill>
+                  <a:srgbClr val="333333"/>
+                </a:solidFill>
+                <a:latin typeface="Calibri"/>
+              </a:defRPr>
+            </a:pPr>
+            <a:r>
+              <a:t>4. Diez bancos: liquidacion interbancaria sin intermediario:</a:t>
+            </a:r>
+          </a:p>
+          <a:p>
+            <a:pPr lvl="1">
+              <a:spcAft>
+                <a:spcPts val="400"/>
+              </a:spcAft>
+              <a:defRPr sz="1700">
+                <a:solidFill>
+                  <a:srgbClr val="666666"/>
+                </a:solidFill>
+                <a:latin typeface="Calibri"/>
+              </a:defRPr>
+            </a:pPr>
+            <a:r>
+              <a:t>    Blockchain. Caso arquetipico (ver HKMA eTradeConnect). Evita intermediario y detecta fraude.</a:t>
+            </a:r>
+          </a:p>
+          <a:p>
+            <a:pPr>
+              <a:spcAft>
+                <a:spcPts val="800"/>
+              </a:spcAft>
+              <a:defRPr sz="2000">
+                <a:solidFill>
+                  <a:srgbClr val="333333"/>
+                </a:solidFill>
+                <a:latin typeface="Calibri"/>
+              </a:defRPr>
+            </a:pPr>
+            <a:r>
+              <a:t>5. Empresa rastrea envios internos entre almacenes:</a:t>
+            </a:r>
+          </a:p>
+          <a:p>
+            <a:pPr lvl="1">
+              <a:spcAft>
+                <a:spcPts val="400"/>
+              </a:spcAft>
+              <a:defRPr sz="1700">
+                <a:solidFill>
+                  <a:srgbClr val="666666"/>
+                </a:solidFill>
+                <a:latin typeface="Calibri"/>
+              </a:defRPr>
+            </a:pPr>
+            <a:r>
+              <a:t>    BD tradicional o ERP. Un solo actor — no hay problema de confianza.</a:t>
+            </a:r>
+          </a:p>
+          <a:p>
+            <a:pPr>
+              <a:spcAft>
+                <a:spcPts val="800"/>
+              </a:spcAft>
+              <a:defRPr sz="2000">
+                <a:solidFill>
+                  <a:srgbClr val="333333"/>
+                </a:solidFill>
+                <a:latin typeface="Calibri"/>
+              </a:defRPr>
+            </a:pPr>
+            <a:r>
+              <a:t>6. Consorcio de 50 productores certifica origen:</a:t>
+            </a:r>
+          </a:p>
+          <a:p>
+            <a:pPr lvl="1">
+              <a:spcAft>
+                <a:spcPts val="400"/>
+              </a:spcAft>
+              <a:defRPr sz="1700">
+                <a:solidFill>
+                  <a:srgbClr val="666666"/>
+                </a:solidFill>
+                <a:latin typeface="Calibri"/>
+              </a:defRPr>
+            </a:pPr>
+            <a:r>
+              <a:t>    Blockchain. Multiples orgs, desconfianza posible, certificacion verificable.</a:t>
+            </a:r>
+          </a:p>
+          <a:p>
+            <a:pPr lvl="1">
+              <a:spcAft>
+                <a:spcPts val="400"/>
+              </a:spcAft>
+              <a:defRPr sz="1700">
+                <a:solidFill>
+                  <a:srgbClr val="666666"/>
+                </a:solidFill>
+                <a:latin typeface="Calibri"/>
+              </a:defRPr>
+            </a:pPr>
+            <a:r>
+              <a:t>    Ver caso Walmart Food Trust.</a:t>
+            </a:r>
+          </a:p>
+        </p:txBody>
+      </p:sp>
+    </p:spTree>
+  </p:cSld>
+  <p:clrMapOvr>
+    <a:masterClrMapping/>
+  </p:clrMapOvr>
+</p:sld>
+</file>
+
+<file path=ppt/slides/slide18.xml><?xml version="1.0" encoding="utf-8"?>
+<p:sld xmlns:a="http://schemas.openxmlformats.org/drawingml/2006/main" xmlns:r="http://schemas.openxmlformats.org/officeDocument/2006/relationships" xmlns:p="http://schemas.openxmlformats.org/presentationml/2006/main">
+  <p:cSld>
+    <p:spTree>
+      <p:nvGrpSpPr>
+        <p:cNvPr id="1" name=""/>
+        <p:cNvGrpSpPr/>
+        <p:nvPr/>
+      </p:nvGrpSpPr>
+      <p:grpSpPr>
+        <a:xfrm>
+          <a:off x="0" y="0"/>
+          <a:ext cx="0" cy="0"/>
+          <a:chOff x="0" y="0"/>
+          <a:chExt cx="0" cy="0"/>
+        </a:xfrm>
+      </p:grpSpPr>
+      <p:sp>
+        <p:nvSpPr>
+          <p:cNvPr id="2" name="Rectangle 1"/>
+          <p:cNvSpPr/>
+          <p:nvPr/>
+        </p:nvSpPr>
+        <p:spPr>
+          <a:xfrm>
+            <a:off x="0" y="0"/>
+            <a:ext cx="12188952" cy="73152"/>
+          </a:xfrm>
+          <a:prstGeom prst="rect">
+            <a:avLst/>
+          </a:prstGeom>
+          <a:solidFill>
+            <a:srgbClr val="22627E"/>
+          </a:solidFill>
+          <a:ln>
+            <a:noFill/>
+          </a:ln>
+        </p:spPr>
+        <p:style>
+          <a:lnRef idx="1">
+            <a:schemeClr val="accent1"/>
+          </a:lnRef>
+          <a:fillRef idx="3">
+            <a:schemeClr val="accent1"/>
+          </a:fillRef>
+          <a:effectRef idx="2">
+            <a:schemeClr val="accent1"/>
+          </a:effectRef>
+          <a:fontRef idx="minor">
+            <a:schemeClr val="lt1"/>
+          </a:fontRef>
+        </p:style>
+        <p:txBody>
+          <a:bodyPr rtlCol="0" anchor="ctr"/>
+          <a:lstStyle/>
+          <a:p>
+            <a:pPr algn="ctr"/>
+            <a:endParaRPr/>
+          </a:p>
+        </p:txBody>
+      </p:sp>
+      <p:sp>
+        <p:nvSpPr>
+          <p:cNvPr id="3" name="TextBox 2"/>
+          <p:cNvSpPr txBox="1"/>
+          <p:nvPr/>
+        </p:nvSpPr>
+        <p:spPr>
+          <a:xfrm>
+            <a:off x="457200" y="274320"/>
+            <a:ext cx="10972800" cy="731520"/>
+          </a:xfrm>
+          <a:prstGeom prst="rect">
+            <a:avLst/>
+          </a:prstGeom>
+          <a:noFill/>
+        </p:spPr>
+        <p:txBody>
+          <a:bodyPr wrap="square"/>
+          <a:lstStyle/>
+          <a:p>
+            <a:pPr algn="l">
+              <a:defRPr sz="3200" b="1">
+                <a:solidFill>
+                  <a:srgbClr val="22627E"/>
+                </a:solidFill>
+                <a:latin typeface="Calibri"/>
+              </a:defRPr>
+            </a:pPr>
+            <a:r>
+              <a:t>Respuestas al repaso</a:t>
+            </a:r>
+          </a:p>
+        </p:txBody>
+      </p:sp>
+      <p:sp>
+        <p:nvSpPr>
+          <p:cNvPr id="4" name="Rectangle 3"/>
+          <p:cNvSpPr/>
+          <p:nvPr/>
+        </p:nvSpPr>
+        <p:spPr>
+          <a:xfrm>
+            <a:off x="457200" y="1051560"/>
+            <a:ext cx="10972800" cy="27432"/>
+          </a:xfrm>
+          <a:prstGeom prst="rect">
+            <a:avLst/>
+          </a:prstGeom>
+          <a:solidFill>
+            <a:srgbClr val="22627E"/>
+          </a:solidFill>
+          <a:ln>
+            <a:noFill/>
+          </a:ln>
+        </p:spPr>
+        <p:style>
+          <a:lnRef idx="1">
+            <a:schemeClr val="accent1"/>
+          </a:lnRef>
+          <a:fillRef idx="3">
+            <a:schemeClr val="accent1"/>
+          </a:fillRef>
+          <a:effectRef idx="2">
+            <a:schemeClr val="accent1"/>
+          </a:effectRef>
+          <a:fontRef idx="minor">
+            <a:schemeClr val="lt1"/>
+          </a:fontRef>
+        </p:style>
+        <p:txBody>
+          <a:bodyPr rtlCol="0" anchor="ctr"/>
+          <a:lstStyle/>
+          <a:p>
+            <a:pPr algn="ctr"/>
+            <a:endParaRPr/>
+          </a:p>
+        </p:txBody>
+      </p:sp>
+      <p:sp>
+        <p:nvSpPr>
+          <p:cNvPr id="5" name="TextBox 4"/>
+          <p:cNvSpPr txBox="1"/>
+          <p:nvPr/>
+        </p:nvSpPr>
+        <p:spPr>
+          <a:xfrm>
+            <a:off x="640080" y="1124712"/>
+            <a:ext cx="10515600" cy="4431983"/>
+          </a:xfrm>
+          <a:prstGeom prst="rect">
+            <a:avLst/>
+          </a:prstGeom>
+          <a:noFill/>
+        </p:spPr>
+        <p:txBody>
+          <a:bodyPr wrap="square">
+            <a:spAutoFit/>
+          </a:bodyPr>
+          <a:lstStyle/>
+          <a:p>
+            <a:pPr>
+              <a:spcAft>
+                <a:spcPts val="800"/>
+              </a:spcAft>
+              <a:defRPr sz="2000">
+                <a:solidFill>
+                  <a:srgbClr val="333333"/>
+                </a:solidFill>
+                <a:latin typeface="Calibri"/>
+              </a:defRPr>
+            </a:pPr>
+            <a:r>
+              <a:rPr sz="2400" dirty="0"/>
+              <a:t>1. Tres </a:t>
+            </a:r>
+            <a:r>
+              <a:rPr sz="2400" dirty="0" err="1"/>
+              <a:t>proyectos</a:t>
+            </a:r>
+            <a:r>
+              <a:rPr sz="2400" dirty="0"/>
+              <a:t> </a:t>
+            </a:r>
+            <a:r>
+              <a:rPr sz="2400" dirty="0" err="1"/>
+              <a:t>en</a:t>
+            </a:r>
+            <a:r>
+              <a:rPr sz="2400" dirty="0"/>
+              <a:t> </a:t>
+            </a:r>
+            <a:r>
+              <a:rPr sz="2400" dirty="0" err="1"/>
+              <a:t>produccion</a:t>
+            </a:r>
+            <a:r>
+              <a:rPr sz="2400" dirty="0"/>
+              <a:t>:</a:t>
+            </a:r>
+          </a:p>
+          <a:p>
+            <a:pPr lvl="1">
+              <a:spcAft>
+                <a:spcPts val="400"/>
+              </a:spcAft>
+              <a:defRPr sz="1700">
+                <a:solidFill>
+                  <a:srgbClr val="666666"/>
+                </a:solidFill>
+                <a:latin typeface="Calibri"/>
+              </a:defRPr>
+            </a:pPr>
+            <a:r>
+              <a:rPr sz="1600" dirty="0"/>
+              <a:t>    Walmart Food Trust (</a:t>
+            </a:r>
+            <a:r>
+              <a:rPr sz="1600" dirty="0" err="1"/>
+              <a:t>trazabilidad</a:t>
+            </a:r>
+            <a:r>
+              <a:rPr sz="1600" dirty="0"/>
+              <a:t> alimentaria).</a:t>
+            </a:r>
+          </a:p>
+          <a:p>
+            <a:pPr lvl="1">
+              <a:spcAft>
+                <a:spcPts val="400"/>
+              </a:spcAft>
+              <a:defRPr sz="1700">
+                <a:solidFill>
+                  <a:srgbClr val="666666"/>
+                </a:solidFill>
+                <a:latin typeface="Calibri"/>
+              </a:defRPr>
+            </a:pPr>
+            <a:r>
+              <a:rPr sz="1600" dirty="0"/>
+              <a:t>    HKMA </a:t>
+            </a:r>
+            <a:r>
+              <a:rPr sz="1600" dirty="0" err="1"/>
+              <a:t>eTradeConnect</a:t>
+            </a:r>
+            <a:r>
+              <a:rPr sz="1600" dirty="0"/>
+              <a:t> (trade finance </a:t>
+            </a:r>
+            <a:r>
+              <a:rPr sz="1600" dirty="0" err="1"/>
+              <a:t>bancos</a:t>
+            </a:r>
+            <a:r>
+              <a:rPr sz="1600" dirty="0"/>
+              <a:t> Hong Kong).</a:t>
+            </a:r>
+          </a:p>
+          <a:p>
+            <a:pPr lvl="1">
+              <a:spcAft>
+                <a:spcPts val="400"/>
+              </a:spcAft>
+              <a:defRPr sz="1700">
+                <a:solidFill>
+                  <a:srgbClr val="666666"/>
+                </a:solidFill>
+                <a:latin typeface="Calibri"/>
+              </a:defRPr>
+            </a:pPr>
+            <a:r>
+              <a:rPr sz="1600" dirty="0"/>
+              <a:t>    ANZ + </a:t>
+            </a:r>
+            <a:r>
+              <a:rPr sz="1600" dirty="0" err="1"/>
+              <a:t>Scentre</a:t>
+            </a:r>
+            <a:r>
+              <a:rPr sz="1600" dirty="0"/>
+              <a:t> Group (</a:t>
+            </a:r>
+            <a:r>
+              <a:rPr sz="1600" dirty="0" err="1"/>
+              <a:t>tokenizacion</a:t>
+            </a:r>
+            <a:r>
+              <a:rPr sz="1600" dirty="0"/>
+              <a:t> de </a:t>
+            </a:r>
+            <a:r>
+              <a:rPr sz="1600" dirty="0" err="1"/>
+              <a:t>alquileres</a:t>
+            </a:r>
+            <a:r>
+              <a:rPr sz="1600" dirty="0"/>
+              <a:t> </a:t>
+            </a:r>
+            <a:r>
+              <a:rPr sz="1600" dirty="0" err="1"/>
+              <a:t>comerciales</a:t>
+            </a:r>
+            <a:r>
+              <a:rPr sz="1600" dirty="0"/>
+              <a:t>).</a:t>
+            </a:r>
+          </a:p>
+          <a:p>
+            <a:pPr>
+              <a:spcAft>
+                <a:spcPts val="800"/>
+              </a:spcAft>
+              <a:defRPr sz="2000">
+                <a:solidFill>
+                  <a:srgbClr val="333333"/>
+                </a:solidFill>
+                <a:latin typeface="Calibri"/>
+              </a:defRPr>
+            </a:pPr>
+            <a:r>
+              <a:rPr sz="2400" dirty="0"/>
+              <a:t>2. Dos </a:t>
+            </a:r>
+            <a:r>
+              <a:rPr sz="2400" dirty="0" err="1"/>
+              <a:t>fracasos</a:t>
+            </a:r>
+            <a:r>
+              <a:rPr sz="2400" dirty="0"/>
+              <a:t> y </a:t>
+            </a:r>
+            <a:r>
+              <a:rPr sz="2400" dirty="0" err="1"/>
+              <a:t>su</a:t>
+            </a:r>
+            <a:r>
+              <a:rPr sz="2400" dirty="0"/>
+              <a:t> razon:</a:t>
+            </a:r>
+          </a:p>
+          <a:p>
+            <a:pPr lvl="1">
+              <a:spcAft>
+                <a:spcPts val="400"/>
+              </a:spcAft>
+              <a:defRPr sz="1700">
+                <a:solidFill>
+                  <a:srgbClr val="666666"/>
+                </a:solidFill>
+                <a:latin typeface="Calibri"/>
+              </a:defRPr>
+            </a:pPr>
+            <a:r>
+              <a:rPr sz="1600" dirty="0"/>
+              <a:t>    </a:t>
+            </a:r>
+            <a:r>
+              <a:rPr sz="1600" dirty="0" err="1"/>
+              <a:t>TradeLens</a:t>
+            </a:r>
+            <a:r>
+              <a:rPr sz="1600" dirty="0"/>
+              <a:t> (</a:t>
+            </a:r>
+            <a:r>
+              <a:rPr sz="1600" dirty="0" err="1"/>
+              <a:t>Maersk+IBM</a:t>
+            </a:r>
+            <a:r>
+              <a:rPr sz="1600" dirty="0"/>
+              <a:t>) — </a:t>
+            </a:r>
+            <a:r>
+              <a:rPr sz="1600" dirty="0" err="1"/>
+              <a:t>gobernanza</a:t>
+            </a:r>
+            <a:r>
+              <a:rPr sz="1600" dirty="0"/>
+              <a:t>: </a:t>
+            </a:r>
+            <a:r>
+              <a:rPr sz="1600" dirty="0" err="1"/>
+              <a:t>fundador</a:t>
+            </a:r>
+            <a:r>
+              <a:rPr sz="1600" dirty="0"/>
+              <a:t> </a:t>
+            </a:r>
+            <a:r>
+              <a:rPr sz="1600" dirty="0" err="1"/>
+              <a:t>dominante</a:t>
+            </a:r>
+            <a:r>
+              <a:rPr sz="1600" dirty="0"/>
+              <a:t> </a:t>
+            </a:r>
+            <a:r>
+              <a:rPr sz="1600" dirty="0" err="1"/>
+              <a:t>ahuyento</a:t>
+            </a:r>
+            <a:r>
+              <a:rPr sz="1600" dirty="0"/>
+              <a:t> </a:t>
+            </a:r>
+            <a:r>
+              <a:rPr sz="1600" dirty="0" err="1"/>
+              <a:t>competidores</a:t>
+            </a:r>
+            <a:r>
+              <a:rPr sz="1600" dirty="0"/>
+              <a:t>.</a:t>
+            </a:r>
+          </a:p>
+          <a:p>
+            <a:pPr lvl="1">
+              <a:spcAft>
+                <a:spcPts val="400"/>
+              </a:spcAft>
+              <a:defRPr sz="1700">
+                <a:solidFill>
+                  <a:srgbClr val="666666"/>
+                </a:solidFill>
+                <a:latin typeface="Calibri"/>
+              </a:defRPr>
+            </a:pPr>
+            <a:r>
+              <a:rPr sz="1600" dirty="0"/>
+              <a:t>    B3i (</a:t>
+            </a:r>
+            <a:r>
+              <a:rPr sz="1600" dirty="0" err="1"/>
+              <a:t>reaseguros</a:t>
+            </a:r>
+            <a:r>
+              <a:rPr sz="1600" dirty="0"/>
+              <a:t>) — </a:t>
+            </a:r>
+            <a:r>
+              <a:rPr sz="1600" dirty="0" err="1"/>
+              <a:t>modelo</a:t>
+            </a:r>
+            <a:r>
+              <a:rPr sz="1600" dirty="0"/>
+              <a:t> de </a:t>
+            </a:r>
+            <a:r>
+              <a:rPr sz="1600" dirty="0" err="1"/>
+              <a:t>negocio</a:t>
+            </a:r>
+            <a:r>
+              <a:rPr sz="1600" dirty="0"/>
+              <a:t>: sin </a:t>
+            </a:r>
+            <a:r>
+              <a:rPr sz="1600" dirty="0" err="1"/>
+              <a:t>ingresos</a:t>
+            </a:r>
+            <a:r>
+              <a:rPr sz="1600" dirty="0"/>
+              <a:t>, capital se </a:t>
+            </a:r>
+            <a:r>
+              <a:rPr sz="1600" dirty="0" err="1"/>
+              <a:t>agoto</a:t>
+            </a:r>
+            <a:r>
+              <a:rPr sz="1600" dirty="0"/>
+              <a:t>.</a:t>
+            </a:r>
+          </a:p>
+          <a:p>
+            <a:pPr>
+              <a:spcAft>
+                <a:spcPts val="800"/>
+              </a:spcAft>
+              <a:defRPr sz="2000">
+                <a:solidFill>
+                  <a:srgbClr val="333333"/>
+                </a:solidFill>
+                <a:latin typeface="Calibri"/>
+              </a:defRPr>
+            </a:pPr>
+            <a:r>
+              <a:rPr sz="2400" dirty="0"/>
+              <a:t>3. Arbol de decision (5 </a:t>
+            </a:r>
+            <a:r>
+              <a:rPr sz="2400" dirty="0" err="1"/>
+              <a:t>preguntas</a:t>
+            </a:r>
+            <a:r>
+              <a:rPr sz="2400" dirty="0"/>
+              <a:t>):</a:t>
+            </a:r>
+          </a:p>
+          <a:p>
+            <a:pPr lvl="1">
+              <a:spcAft>
+                <a:spcPts val="400"/>
+              </a:spcAft>
+              <a:defRPr sz="1700">
+                <a:solidFill>
+                  <a:srgbClr val="666666"/>
+                </a:solidFill>
+                <a:latin typeface="Calibri"/>
+              </a:defRPr>
+            </a:pPr>
+            <a:r>
+              <a:rPr sz="1600" dirty="0"/>
+              <a:t>    ¿Multiples partes sin confianza </a:t>
+            </a:r>
+            <a:r>
+              <a:rPr sz="1600" dirty="0" err="1"/>
+              <a:t>mutua</a:t>
+            </a:r>
+            <a:r>
+              <a:rPr sz="1600" dirty="0"/>
+              <a:t>?</a:t>
+            </a:r>
+          </a:p>
+          <a:p>
+            <a:pPr lvl="1">
+              <a:spcAft>
+                <a:spcPts val="400"/>
+              </a:spcAft>
+              <a:defRPr sz="1700">
+                <a:solidFill>
+                  <a:srgbClr val="666666"/>
+                </a:solidFill>
+                <a:latin typeface="Calibri"/>
+              </a:defRPr>
+            </a:pPr>
+            <a:r>
+              <a:rPr sz="1600" dirty="0"/>
+              <a:t>    ¿</a:t>
+            </a:r>
+            <a:r>
+              <a:rPr sz="1600" dirty="0" err="1"/>
+              <a:t>Necesitan</a:t>
+            </a:r>
+            <a:r>
+              <a:rPr sz="1600" dirty="0"/>
+              <a:t> </a:t>
+            </a:r>
+            <a:r>
+              <a:rPr sz="1600" dirty="0" err="1"/>
+              <a:t>compartir</a:t>
+            </a:r>
+            <a:r>
+              <a:rPr sz="1600" dirty="0"/>
+              <a:t> </a:t>
+            </a:r>
+            <a:r>
+              <a:rPr sz="1600" dirty="0" err="1"/>
+              <a:t>datos</a:t>
+            </a:r>
+            <a:r>
+              <a:rPr sz="1600" dirty="0"/>
+              <a:t>?</a:t>
+            </a:r>
+          </a:p>
+          <a:p>
+            <a:pPr lvl="1">
+              <a:spcAft>
+                <a:spcPts val="400"/>
+              </a:spcAft>
+              <a:defRPr sz="1700">
+                <a:solidFill>
+                  <a:srgbClr val="666666"/>
+                </a:solidFill>
+                <a:latin typeface="Calibri"/>
+              </a:defRPr>
+            </a:pPr>
+            <a:r>
+              <a:rPr sz="1600" dirty="0"/>
+              <a:t>    ¿</a:t>
+            </a:r>
+            <a:r>
+              <a:rPr sz="1600" dirty="0" err="1"/>
+              <a:t>Inmutabilidad</a:t>
+            </a:r>
+            <a:r>
+              <a:rPr sz="1600" dirty="0"/>
+              <a:t> del </a:t>
+            </a:r>
+            <a:r>
+              <a:rPr sz="1600" dirty="0" err="1"/>
+              <a:t>registro</a:t>
+            </a:r>
+            <a:r>
+              <a:rPr sz="1600" dirty="0"/>
+              <a:t> es </a:t>
+            </a:r>
+            <a:r>
+              <a:rPr sz="1600" dirty="0" err="1"/>
+              <a:t>critica</a:t>
+            </a:r>
+            <a:r>
+              <a:rPr sz="1600" dirty="0"/>
+              <a:t>?</a:t>
+            </a:r>
+          </a:p>
+          <a:p>
+            <a:pPr lvl="1">
+              <a:spcAft>
+                <a:spcPts val="400"/>
+              </a:spcAft>
+              <a:defRPr sz="1700">
+                <a:solidFill>
+                  <a:srgbClr val="666666"/>
+                </a:solidFill>
+                <a:latin typeface="Calibri"/>
+              </a:defRPr>
+            </a:pPr>
+            <a:r>
+              <a:rPr sz="1600" dirty="0"/>
+              <a:t>    ¿Reglas </a:t>
+            </a:r>
+            <a:r>
+              <a:rPr sz="1600" dirty="0" err="1"/>
+              <a:t>deben</a:t>
+            </a:r>
+            <a:r>
+              <a:rPr sz="1600" dirty="0"/>
+              <a:t> ser </a:t>
+            </a:r>
+            <a:r>
+              <a:rPr sz="1600" dirty="0" err="1"/>
+              <a:t>verificables</a:t>
+            </a:r>
+            <a:r>
+              <a:rPr sz="1600" dirty="0"/>
+              <a:t> </a:t>
+            </a:r>
+            <a:r>
+              <a:rPr sz="1600" dirty="0" err="1"/>
+              <a:t>por</a:t>
+            </a:r>
+            <a:r>
+              <a:rPr sz="1600" dirty="0"/>
+              <a:t> </a:t>
+            </a:r>
+            <a:r>
+              <a:rPr sz="1600" dirty="0" err="1"/>
+              <a:t>todos</a:t>
+            </a:r>
+            <a:r>
+              <a:rPr sz="1600" dirty="0"/>
+              <a:t>?</a:t>
+            </a:r>
+          </a:p>
+          <a:p>
+            <a:pPr lvl="1">
+              <a:spcAft>
+                <a:spcPts val="400"/>
+              </a:spcAft>
+              <a:defRPr sz="1700">
+                <a:solidFill>
+                  <a:srgbClr val="666666"/>
+                </a:solidFill>
+                <a:latin typeface="Calibri"/>
+              </a:defRPr>
+            </a:pPr>
+            <a:r>
+              <a:rPr sz="1600" dirty="0"/>
+              <a:t>    ¿</a:t>
+            </a:r>
+            <a:r>
+              <a:rPr sz="1600" dirty="0" err="1"/>
+              <a:t>Ningun</a:t>
+            </a:r>
+            <a:r>
+              <a:rPr sz="1600" dirty="0"/>
+              <a:t> actor </a:t>
+            </a:r>
+            <a:r>
+              <a:rPr sz="1600" dirty="0" err="1"/>
+              <a:t>puede</a:t>
+            </a:r>
+            <a:r>
+              <a:rPr sz="1600" dirty="0"/>
+              <a:t> ser </a:t>
+            </a:r>
+            <a:r>
+              <a:rPr sz="1600" dirty="0" err="1"/>
+              <a:t>el</a:t>
+            </a:r>
+            <a:r>
+              <a:rPr sz="1600" dirty="0"/>
+              <a:t> '</a:t>
+            </a:r>
+            <a:r>
+              <a:rPr sz="1600" dirty="0" err="1"/>
+              <a:t>dueno</a:t>
+            </a:r>
+            <a:r>
+              <a:rPr sz="1600" dirty="0"/>
+              <a:t>'?</a:t>
+            </a:r>
+          </a:p>
+        </p:txBody>
+      </p:sp>
+    </p:spTree>
+  </p:cSld>
+  <p:clrMapOvr>
+    <a:masterClrMapping/>
+  </p:clrMapOvr>
+</p:sld>
+</file>
+
+<file path=ppt/slides/slide19.xml><?xml version="1.0" encoding="utf-8"?>
+<p:sld xmlns:a="http://schemas.openxmlformats.org/drawingml/2006/main" xmlns:r="http://schemas.openxmlformats.org/officeDocument/2006/relationships" xmlns:p="http://schemas.openxmlformats.org/presentationml/2006/main">
+  <p:cSld>
+    <p:spTree>
+      <p:nvGrpSpPr>
+        <p:cNvPr id="1" name="">
+          <a:extLst>
+            <a:ext uri="{FF2B5EF4-FFF2-40B4-BE49-F238E27FC236}">
+              <a16:creationId xmlns:a16="http://schemas.microsoft.com/office/drawing/2014/main" id="{08EC5411-F105-953A-1FC0-A698681F8ED6}"/>
+            </a:ext>
+          </a:extLst>
+        </p:cNvPr>
+        <p:cNvGrpSpPr/>
+        <p:nvPr/>
+      </p:nvGrpSpPr>
+      <p:grpSpPr>
+        <a:xfrm>
+          <a:off x="0" y="0"/>
+          <a:ext cx="0" cy="0"/>
+          <a:chOff x="0" y="0"/>
+          <a:chExt cx="0" cy="0"/>
+        </a:xfrm>
+      </p:grpSpPr>
+      <p:sp>
+        <p:nvSpPr>
+          <p:cNvPr id="2" name="Rectangle 1">
+            <a:extLst>
+              <a:ext uri="{FF2B5EF4-FFF2-40B4-BE49-F238E27FC236}">
+                <a16:creationId xmlns:a16="http://schemas.microsoft.com/office/drawing/2014/main" id="{99051F07-1A5E-0150-EADF-BC88532C3153}"/>
+              </a:ext>
+            </a:extLst>
+          </p:cNvPr>
+          <p:cNvSpPr/>
+          <p:nvPr/>
+        </p:nvSpPr>
+        <p:spPr>
+          <a:xfrm>
+            <a:off x="0" y="0"/>
+            <a:ext cx="12188952" cy="73152"/>
+          </a:xfrm>
+          <a:prstGeom prst="rect">
+            <a:avLst/>
+          </a:prstGeom>
+          <a:solidFill>
+            <a:srgbClr val="22627E"/>
+          </a:solidFill>
+          <a:ln>
+            <a:noFill/>
+          </a:ln>
+        </p:spPr>
+        <p:style>
+          <a:lnRef idx="1">
+            <a:schemeClr val="accent1"/>
+          </a:lnRef>
+          <a:fillRef idx="3">
+            <a:schemeClr val="accent1"/>
+          </a:fillRef>
+          <a:effectRef idx="2">
+            <a:schemeClr val="accent1"/>
+          </a:effectRef>
+          <a:fontRef idx="minor">
+            <a:schemeClr val="lt1"/>
+          </a:fontRef>
+        </p:style>
+        <p:txBody>
+          <a:bodyPr rtlCol="0" anchor="ctr"/>
+          <a:lstStyle/>
+          <a:p>
+            <a:pPr algn="ctr"/>
+            <a:endParaRPr/>
+          </a:p>
+        </p:txBody>
+      </p:sp>
+      <p:sp>
+        <p:nvSpPr>
+          <p:cNvPr id="3" name="TextBox 2">
+            <a:extLst>
+              <a:ext uri="{FF2B5EF4-FFF2-40B4-BE49-F238E27FC236}">
+                <a16:creationId xmlns:a16="http://schemas.microsoft.com/office/drawing/2014/main" id="{F293EF30-C05E-980B-025C-0444FAA77BE5}"/>
+              </a:ext>
+            </a:extLst>
+          </p:cNvPr>
+          <p:cNvSpPr txBox="1"/>
+          <p:nvPr/>
+        </p:nvSpPr>
+        <p:spPr>
+          <a:xfrm>
+            <a:off x="457200" y="274320"/>
+            <a:ext cx="10972800" cy="731520"/>
+          </a:xfrm>
+          <a:prstGeom prst="rect">
+            <a:avLst/>
+          </a:prstGeom>
+          <a:noFill/>
+        </p:spPr>
+        <p:txBody>
+          <a:bodyPr wrap="square"/>
+          <a:lstStyle/>
+          <a:p>
+            <a:pPr algn="l">
+              <a:defRPr sz="3200" b="1">
+                <a:solidFill>
+                  <a:srgbClr val="22627E"/>
+                </a:solidFill>
+                <a:latin typeface="Calibri"/>
+              </a:defRPr>
+            </a:pPr>
+            <a:r>
+              <a:t>Respuestas al repaso</a:t>
+            </a:r>
+          </a:p>
+        </p:txBody>
+      </p:sp>
+      <p:sp>
+        <p:nvSpPr>
+          <p:cNvPr id="4" name="Rectangle 3">
+            <a:extLst>
+              <a:ext uri="{FF2B5EF4-FFF2-40B4-BE49-F238E27FC236}">
+                <a16:creationId xmlns:a16="http://schemas.microsoft.com/office/drawing/2014/main" id="{3383D7CD-DDA8-A854-1BA3-E959426B2F63}"/>
+              </a:ext>
+            </a:extLst>
+          </p:cNvPr>
+          <p:cNvSpPr/>
+          <p:nvPr/>
+        </p:nvSpPr>
+        <p:spPr>
+          <a:xfrm>
+            <a:off x="457200" y="1051560"/>
+            <a:ext cx="10972800" cy="27432"/>
+          </a:xfrm>
+          <a:prstGeom prst="rect">
+            <a:avLst/>
+          </a:prstGeom>
+          <a:solidFill>
+            <a:srgbClr val="22627E"/>
+          </a:solidFill>
+          <a:ln>
+            <a:noFill/>
+          </a:ln>
+        </p:spPr>
+        <p:style>
+          <a:lnRef idx="1">
+            <a:schemeClr val="accent1"/>
+          </a:lnRef>
+          <a:fillRef idx="3">
+            <a:schemeClr val="accent1"/>
+          </a:fillRef>
+          <a:effectRef idx="2">
+            <a:schemeClr val="accent1"/>
+          </a:effectRef>
+          <a:fontRef idx="minor">
+            <a:schemeClr val="lt1"/>
+          </a:fontRef>
+        </p:style>
+        <p:txBody>
+          <a:bodyPr rtlCol="0" anchor="ctr"/>
+          <a:lstStyle/>
+          <a:p>
+            <a:pPr algn="ctr"/>
+            <a:endParaRPr/>
+          </a:p>
+        </p:txBody>
+      </p:sp>
+      <p:sp>
+        <p:nvSpPr>
+          <p:cNvPr id="7" name="CuadroTexto 6">
+            <a:extLst>
+              <a:ext uri="{FF2B5EF4-FFF2-40B4-BE49-F238E27FC236}">
+                <a16:creationId xmlns:a16="http://schemas.microsoft.com/office/drawing/2014/main" id="{DDBC02C8-7317-6843-F0AD-ABB41983B497}"/>
+              </a:ext>
+            </a:extLst>
+          </p:cNvPr>
+          <p:cNvSpPr txBox="1"/>
+          <p:nvPr/>
+        </p:nvSpPr>
+        <p:spPr>
+          <a:xfrm>
+            <a:off x="781215" y="1234161"/>
+            <a:ext cx="6142382" cy="3611245"/>
+          </a:xfrm>
+          <a:prstGeom prst="rect">
+            <a:avLst/>
+          </a:prstGeom>
+          <a:noFill/>
+        </p:spPr>
+        <p:txBody>
+          <a:bodyPr wrap="square">
+            <a:spAutoFit/>
+          </a:bodyPr>
+          <a:lstStyle/>
+          <a:p>
+            <a:pPr lvl="1">
+              <a:spcAft>
+                <a:spcPts val="400"/>
+              </a:spcAft>
+              <a:defRPr sz="1700">
+                <a:solidFill>
+                  <a:srgbClr val="666666"/>
+                </a:solidFill>
+                <a:latin typeface="Calibri"/>
+              </a:defRPr>
+            </a:pPr>
+            <a:endParaRPr lang="es-ES" sz="1600" dirty="0"/>
+          </a:p>
+          <a:p>
+            <a:pPr>
+              <a:spcAft>
+                <a:spcPts val="800"/>
+              </a:spcAft>
+              <a:defRPr sz="2000">
+                <a:solidFill>
+                  <a:srgbClr val="333333"/>
+                </a:solidFill>
+                <a:latin typeface="Calibri"/>
+              </a:defRPr>
+            </a:pPr>
+            <a:r>
+              <a:rPr lang="es-ES" sz="2400" dirty="0"/>
+              <a:t>4. Problema del fundador dominante:</a:t>
+            </a:r>
+          </a:p>
+          <a:p>
+            <a:pPr lvl="1">
+              <a:spcAft>
+                <a:spcPts val="400"/>
+              </a:spcAft>
+              <a:defRPr sz="1700">
+                <a:solidFill>
+                  <a:srgbClr val="666666"/>
+                </a:solidFill>
+                <a:latin typeface="Calibri"/>
+              </a:defRPr>
+            </a:pPr>
+            <a:r>
+              <a:rPr lang="es-ES" sz="1600" dirty="0"/>
+              <a:t>    Cuando una empresa lanza y controla la red, los competidores no se suman.</a:t>
+            </a:r>
+          </a:p>
+          <a:p>
+            <a:pPr lvl="1">
+              <a:spcAft>
+                <a:spcPts val="400"/>
+              </a:spcAft>
+              <a:defRPr sz="1700">
+                <a:solidFill>
+                  <a:srgbClr val="666666"/>
+                </a:solidFill>
+                <a:latin typeface="Calibri"/>
+              </a:defRPr>
+            </a:pPr>
+            <a:r>
+              <a:rPr lang="es-ES" sz="1600" dirty="0"/>
+              <a:t>    Ven un conflicto de intereses: dar datos a un rival.</a:t>
+            </a:r>
+          </a:p>
+          <a:p>
+            <a:pPr lvl="1">
+              <a:spcAft>
+                <a:spcPts val="400"/>
+              </a:spcAft>
+              <a:defRPr sz="1700">
+                <a:solidFill>
+                  <a:srgbClr val="666666"/>
+                </a:solidFill>
+                <a:latin typeface="Calibri"/>
+              </a:defRPr>
+            </a:pPr>
+            <a:r>
+              <a:rPr lang="es-ES" sz="1600" dirty="0"/>
+              <a:t>    Sin competidores, la red no alcanza masa critica -&gt; fracaso.</a:t>
+            </a:r>
+          </a:p>
+          <a:p>
+            <a:pPr>
+              <a:spcAft>
+                <a:spcPts val="800"/>
+              </a:spcAft>
+              <a:defRPr sz="2000">
+                <a:solidFill>
+                  <a:srgbClr val="333333"/>
+                </a:solidFill>
+                <a:latin typeface="Calibri"/>
+              </a:defRPr>
+            </a:pPr>
+            <a:r>
+              <a:rPr lang="es-ES" sz="2400" dirty="0"/>
+              <a:t>5. Respaldo del regulador como factor de </a:t>
+            </a:r>
+            <a:r>
+              <a:rPr lang="es-ES" sz="2400" dirty="0" err="1"/>
+              <a:t>exito</a:t>
+            </a:r>
+            <a:r>
+              <a:rPr lang="es-ES" sz="2400" dirty="0"/>
+              <a:t>:</a:t>
+            </a:r>
+          </a:p>
+          <a:p>
+            <a:pPr lvl="1">
+              <a:spcAft>
+                <a:spcPts val="400"/>
+              </a:spcAft>
+              <a:defRPr sz="1700">
+                <a:solidFill>
+                  <a:srgbClr val="666666"/>
+                </a:solidFill>
+                <a:latin typeface="Calibri"/>
+              </a:defRPr>
+            </a:pPr>
+            <a:r>
+              <a:rPr lang="es-ES" sz="1600" dirty="0"/>
+              <a:t>    Impone </a:t>
+            </a:r>
+            <a:r>
+              <a:rPr lang="es-ES" sz="1600" dirty="0" err="1"/>
+              <a:t>adopcion</a:t>
+            </a:r>
+            <a:r>
+              <a:rPr lang="es-ES" sz="1600" dirty="0"/>
+              <a:t> (p.ej. HKMA obligo a bancos de Hong Kong).</a:t>
+            </a:r>
+          </a:p>
+          <a:p>
+            <a:pPr lvl="1">
+              <a:spcAft>
+                <a:spcPts val="400"/>
+              </a:spcAft>
+              <a:defRPr sz="1700">
+                <a:solidFill>
+                  <a:srgbClr val="666666"/>
+                </a:solidFill>
+                <a:latin typeface="Calibri"/>
+              </a:defRPr>
+            </a:pPr>
+            <a:r>
+              <a:rPr lang="es-ES" sz="1600" dirty="0"/>
+              <a:t>    Da legitimidad legal y regulatoria.</a:t>
+            </a:r>
+          </a:p>
+          <a:p>
+            <a:pPr lvl="1">
+              <a:spcAft>
+                <a:spcPts val="400"/>
+              </a:spcAft>
+              <a:defRPr sz="1700">
+                <a:solidFill>
+                  <a:srgbClr val="666666"/>
+                </a:solidFill>
+                <a:latin typeface="Calibri"/>
+              </a:defRPr>
+            </a:pPr>
+            <a:r>
+              <a:rPr lang="es-ES" sz="1600" dirty="0"/>
+              <a:t>    Elimina la incertidumbre sobre si el proyecto cumple la ley.</a:t>
+            </a:r>
+          </a:p>
+          <a:p>
+            <a:pPr lvl="1">
+              <a:spcAft>
+                <a:spcPts val="400"/>
+              </a:spcAft>
+              <a:defRPr sz="1700">
+                <a:solidFill>
+                  <a:srgbClr val="666666"/>
+                </a:solidFill>
+                <a:latin typeface="Calibri"/>
+              </a:defRPr>
+            </a:pPr>
+            <a:r>
+              <a:rPr lang="es-ES" sz="1600" dirty="0"/>
+              <a:t>    </a:t>
+            </a:r>
+            <a:r>
+              <a:rPr lang="es-ES" sz="1600" dirty="0" err="1"/>
+              <a:t>Actua</a:t>
+            </a:r>
+            <a:r>
+              <a:rPr lang="es-ES" sz="1600" dirty="0"/>
+              <a:t> como arbitro en disputas.</a:t>
+            </a:r>
+          </a:p>
+        </p:txBody>
+      </p:sp>
+    </p:spTree>
+    <p:extLst>
+      <p:ext uri="{BB962C8B-B14F-4D97-AF65-F5344CB8AC3E}">
+        <p14:creationId xmlns:p14="http://schemas.microsoft.com/office/powerpoint/2010/main" val="517529700"/>
+      </p:ext>
+    </p:extLst>
+  </p:cSld>
+  <p:clrMapOvr>
+    <a:masterClrMapping/>
+  </p:clrMapOvr>
+</p:sld>
+</file>
+
+<file path=ppt/slides/slide2.xml><?xml version="1.0" encoding="utf-8"?>
+<p:sld xmlns:a="http://schemas.openxmlformats.org/drawingml/2006/main" xmlns:r="http://schemas.openxmlformats.org/officeDocument/2006/relationships" xmlns:p="http://schemas.openxmlformats.org/presentationml/2006/main">
+  <p:cSld>
+    <p:spTree>
+      <p:nvGrpSpPr>
+        <p:cNvPr id="1" name=""/>
+        <p:cNvGrpSpPr/>
+        <p:nvPr/>
+      </p:nvGrpSpPr>
+      <p:grpSpPr>
+        <a:xfrm>
+          <a:off x="0" y="0"/>
+          <a:ext cx="0" cy="0"/>
+          <a:chOff x="0" y="0"/>
+          <a:chExt cx="0" cy="0"/>
+        </a:xfrm>
+      </p:grpSpPr>
+      <p:sp>
+        <p:nvSpPr>
+          <p:cNvPr id="2" name="Rectangle 1"/>
+          <p:cNvSpPr/>
+          <p:nvPr/>
+        </p:nvSpPr>
+        <p:spPr>
+          <a:xfrm>
+            <a:off x="0" y="0"/>
+            <a:ext cx="12188952" cy="6858000"/>
+          </a:xfrm>
+          <a:prstGeom prst="rect">
+            <a:avLst/>
+          </a:prstGeom>
+          <a:solidFill>
+            <a:srgbClr val="22627E"/>
+          </a:solidFill>
+          <a:ln>
+            <a:noFill/>
+          </a:ln>
+        </p:spPr>
+        <p:style>
+          <a:lnRef idx="1">
+            <a:schemeClr val="accent1"/>
+          </a:lnRef>
+          <a:fillRef idx="3">
+            <a:schemeClr val="accent1"/>
+          </a:fillRef>
+          <a:effectRef idx="2">
+            <a:schemeClr val="accent1"/>
+          </a:effectRef>
+          <a:fontRef idx="minor">
+            <a:schemeClr val="lt1"/>
+          </a:fontRef>
+        </p:style>
+        <p:txBody>
+          <a:bodyPr rtlCol="0" anchor="ctr"/>
+          <a:lstStyle/>
+          <a:p>
+            <a:pPr algn="ctr"/>
+            <a:endParaRPr/>
           </a:p>
         </p:txBody>
       </p:sp>
@@ -6000,7 +7483,7 @@
 </file>
 
 <file path=ppt/slides/slide3.xml><?xml version="1.0" encoding="utf-8"?>
-<p:sld xmlns:a="http://schemas.openxmlformats.org/drawingml/2006/main" xmlns:p="http://schemas.openxmlformats.org/presentationml/2006/main" xmlns:r="http://schemas.openxmlformats.org/officeDocument/2006/relationships">
+<p:sld xmlns:a="http://schemas.openxmlformats.org/drawingml/2006/main" xmlns:r="http://schemas.openxmlformats.org/officeDocument/2006/relationships" xmlns:p="http://schemas.openxmlformats.org/presentationml/2006/main">
   <p:cSld>
     <p:spTree>
       <p:nvGrpSpPr>
@@ -6008,7 +7491,14 @@
         <p:cNvGrpSpPr/>
         <p:nvPr/>
       </p:nvGrpSpPr>
-      <p:grpSpPr/>
+      <p:grpSpPr>
+        <a:xfrm>
+          <a:off x="0" y="0"/>
+          <a:ext cx="0" cy="0"/>
+          <a:chOff x="0" y="0"/>
+          <a:chExt cx="0" cy="0"/>
+        </a:xfrm>
+      </p:grpSpPr>
       <p:sp>
         <p:nvSpPr>
           <p:cNvPr id="2" name="Rectangle 1"/>
@@ -6049,6 +7539,7 @@
           <a:lstStyle/>
           <a:p>
             <a:pPr algn="ctr"/>
+            <a:endParaRPr/>
           </a:p>
         </p:txBody>
       </p:sp>
@@ -6126,6 +7617,7 @@
           <a:lstStyle/>
           <a:p>
             <a:pPr algn="ctr"/>
+            <a:endParaRPr/>
           </a:p>
         </p:txBody>
       </p:sp>
@@ -6289,7 +7781,7 @@
 </file>
 
 <file path=ppt/slides/slide4.xml><?xml version="1.0" encoding="utf-8"?>
-<p:sld xmlns:a="http://schemas.openxmlformats.org/drawingml/2006/main" xmlns:p="http://schemas.openxmlformats.org/presentationml/2006/main" xmlns:r="http://schemas.openxmlformats.org/officeDocument/2006/relationships">
+<p:sld xmlns:a="http://schemas.openxmlformats.org/drawingml/2006/main" xmlns:r="http://schemas.openxmlformats.org/officeDocument/2006/relationships" xmlns:p="http://schemas.openxmlformats.org/presentationml/2006/main">
   <p:cSld>
     <p:spTree>
       <p:nvGrpSpPr>
@@ -6297,7 +7789,14 @@
         <p:cNvGrpSpPr/>
         <p:nvPr/>
       </p:nvGrpSpPr>
-      <p:grpSpPr/>
+      <p:grpSpPr>
+        <a:xfrm>
+          <a:off x="0" y="0"/>
+          <a:ext cx="0" cy="0"/>
+          <a:chOff x="0" y="0"/>
+          <a:chExt cx="0" cy="0"/>
+        </a:xfrm>
+      </p:grpSpPr>
       <p:sp>
         <p:nvSpPr>
           <p:cNvPr id="2" name="Rectangle 1"/>
@@ -6338,6 +7837,7 @@
           <a:lstStyle/>
           <a:p>
             <a:pPr algn="ctr"/>
+            <a:endParaRPr/>
           </a:p>
         </p:txBody>
       </p:sp>
@@ -6415,6 +7915,7 @@
           <a:lstStyle/>
           <a:p>
             <a:pPr algn="ctr"/>
+            <a:endParaRPr/>
           </a:p>
         </p:txBody>
       </p:sp>
@@ -6546,7 +8047,7 @@
 </file>
 
 <file path=ppt/slides/slide5.xml><?xml version="1.0" encoding="utf-8"?>
-<p:sld xmlns:a="http://schemas.openxmlformats.org/drawingml/2006/main" xmlns:p="http://schemas.openxmlformats.org/presentationml/2006/main" xmlns:r="http://schemas.openxmlformats.org/officeDocument/2006/relationships">
+<p:sld xmlns:a="http://schemas.openxmlformats.org/drawingml/2006/main" xmlns:r="http://schemas.openxmlformats.org/officeDocument/2006/relationships" xmlns:p="http://schemas.openxmlformats.org/presentationml/2006/main">
   <p:cSld>
     <p:spTree>
       <p:nvGrpSpPr>
@@ -6554,7 +8055,14 @@
         <p:cNvGrpSpPr/>
         <p:nvPr/>
       </p:nvGrpSpPr>
-      <p:grpSpPr/>
+      <p:grpSpPr>
+        <a:xfrm>
+          <a:off x="0" y="0"/>
+          <a:ext cx="0" cy="0"/>
+          <a:chOff x="0" y="0"/>
+          <a:chExt cx="0" cy="0"/>
+        </a:xfrm>
+      </p:grpSpPr>
       <p:sp>
         <p:nvSpPr>
           <p:cNvPr id="2" name="Rectangle 1"/>
@@ -6595,6 +8103,7 @@
           <a:lstStyle/>
           <a:p>
             <a:pPr algn="ctr"/>
+            <a:endParaRPr/>
           </a:p>
         </p:txBody>
       </p:sp>
@@ -6672,6 +8181,7 @@
           <a:lstStyle/>
           <a:p>
             <a:pPr algn="ctr"/>
+            <a:endParaRPr/>
           </a:p>
         </p:txBody>
       </p:sp>
@@ -6803,7 +8313,7 @@
 </file>
 
 <file path=ppt/slides/slide6.xml><?xml version="1.0" encoding="utf-8"?>
-<p:sld xmlns:a="http://schemas.openxmlformats.org/drawingml/2006/main" xmlns:p="http://schemas.openxmlformats.org/presentationml/2006/main" xmlns:r="http://schemas.openxmlformats.org/officeDocument/2006/relationships">
+<p:sld xmlns:a="http://schemas.openxmlformats.org/drawingml/2006/main" xmlns:r="http://schemas.openxmlformats.org/officeDocument/2006/relationships" xmlns:p="http://schemas.openxmlformats.org/presentationml/2006/main">
   <p:cSld>
     <p:spTree>
       <p:nvGrpSpPr>
@@ -6811,7 +8321,14 @@
         <p:cNvGrpSpPr/>
         <p:nvPr/>
       </p:nvGrpSpPr>
-      <p:grpSpPr/>
+      <p:grpSpPr>
+        <a:xfrm>
+          <a:off x="0" y="0"/>
+          <a:ext cx="0" cy="0"/>
+          <a:chOff x="0" y="0"/>
+          <a:chExt cx="0" cy="0"/>
+        </a:xfrm>
+      </p:grpSpPr>
       <p:sp>
         <p:nvSpPr>
           <p:cNvPr id="2" name="Rectangle 1"/>
@@ -6852,6 +8369,7 @@
           <a:lstStyle/>
           <a:p>
             <a:pPr algn="ctr"/>
+            <a:endParaRPr/>
           </a:p>
         </p:txBody>
       </p:sp>
@@ -6929,6 +8447,7 @@
           <a:lstStyle/>
           <a:p>
             <a:pPr algn="ctr"/>
+            <a:endParaRPr/>
           </a:p>
         </p:txBody>
       </p:sp>
@@ -7060,7 +8579,7 @@
 </file>
 
 <file path=ppt/slides/slide7.xml><?xml version="1.0" encoding="utf-8"?>
-<p:sld xmlns:a="http://schemas.openxmlformats.org/drawingml/2006/main" xmlns:p="http://schemas.openxmlformats.org/presentationml/2006/main" xmlns:r="http://schemas.openxmlformats.org/officeDocument/2006/relationships">
+<p:sld xmlns:a="http://schemas.openxmlformats.org/drawingml/2006/main" xmlns:r="http://schemas.openxmlformats.org/officeDocument/2006/relationships" xmlns:p="http://schemas.openxmlformats.org/presentationml/2006/main">
   <p:cSld>
     <p:spTree>
       <p:nvGrpSpPr>
@@ -7068,7 +8587,14 @@
         <p:cNvGrpSpPr/>
         <p:nvPr/>
       </p:nvGrpSpPr>
-      <p:grpSpPr/>
+      <p:grpSpPr>
+        <a:xfrm>
+          <a:off x="0" y="0"/>
+          <a:ext cx="0" cy="0"/>
+          <a:chOff x="0" y="0"/>
+          <a:chExt cx="0" cy="0"/>
+        </a:xfrm>
+      </p:grpSpPr>
       <p:sp>
         <p:nvSpPr>
           <p:cNvPr id="2" name="Rectangle 1"/>
@@ -7109,6 +8635,7 @@
           <a:lstStyle/>
           <a:p>
             <a:pPr algn="ctr"/>
+            <a:endParaRPr/>
           </a:p>
         </p:txBody>
       </p:sp>
@@ -7189,7 +8716,7 @@
 </file>
 
 <file path=ppt/slides/slide8.xml><?xml version="1.0" encoding="utf-8"?>
-<p:sld xmlns:a="http://schemas.openxmlformats.org/drawingml/2006/main" xmlns:p="http://schemas.openxmlformats.org/presentationml/2006/main" xmlns:r="http://schemas.openxmlformats.org/officeDocument/2006/relationships">
+<p:sld xmlns:a="http://schemas.openxmlformats.org/drawingml/2006/main" xmlns:r="http://schemas.openxmlformats.org/officeDocument/2006/relationships" xmlns:p="http://schemas.openxmlformats.org/presentationml/2006/main">
   <p:cSld>
     <p:spTree>
       <p:nvGrpSpPr>
@@ -7197,7 +8724,14 @@
         <p:cNvGrpSpPr/>
         <p:nvPr/>
       </p:nvGrpSpPr>
-      <p:grpSpPr/>
+      <p:grpSpPr>
+        <a:xfrm>
+          <a:off x="0" y="0"/>
+          <a:ext cx="0" cy="0"/>
+          <a:chOff x="0" y="0"/>
+          <a:chExt cx="0" cy="0"/>
+        </a:xfrm>
+      </p:grpSpPr>
       <p:sp>
         <p:nvSpPr>
           <p:cNvPr id="2" name="Rectangle 1"/>
@@ -7238,6 +8772,7 @@
           <a:lstStyle/>
           <a:p>
             <a:pPr algn="ctr"/>
+            <a:endParaRPr/>
           </a:p>
         </p:txBody>
       </p:sp>
@@ -7315,6 +8850,7 @@
           <a:lstStyle/>
           <a:p>
             <a:pPr algn="ctr"/>
+            <a:endParaRPr/>
           </a:p>
         </p:txBody>
       </p:sp>
@@ -7462,7 +8998,7 @@
 </file>
 
 <file path=ppt/slides/slide9.xml><?xml version="1.0" encoding="utf-8"?>
-<p:sld xmlns:a="http://schemas.openxmlformats.org/drawingml/2006/main" xmlns:p="http://schemas.openxmlformats.org/presentationml/2006/main" xmlns:r="http://schemas.openxmlformats.org/officeDocument/2006/relationships">
+<p:sld xmlns:a="http://schemas.openxmlformats.org/drawingml/2006/main" xmlns:r="http://schemas.openxmlformats.org/officeDocument/2006/relationships" xmlns:p="http://schemas.openxmlformats.org/presentationml/2006/main">
   <p:cSld>
     <p:spTree>
       <p:nvGrpSpPr>
@@ -7470,7 +9006,14 @@
         <p:cNvGrpSpPr/>
         <p:nvPr/>
       </p:nvGrpSpPr>
-      <p:grpSpPr/>
+      <p:grpSpPr>
+        <a:xfrm>
+          <a:off x="0" y="0"/>
+          <a:ext cx="0" cy="0"/>
+          <a:chOff x="0" y="0"/>
+          <a:chExt cx="0" cy="0"/>
+        </a:xfrm>
+      </p:grpSpPr>
       <p:sp>
         <p:nvSpPr>
           <p:cNvPr id="2" name="Rectangle 1"/>
@@ -7511,6 +9054,7 @@
           <a:lstStyle/>
           <a:p>
             <a:pPr algn="ctr"/>
+            <a:endParaRPr/>
           </a:p>
         </p:txBody>
       </p:sp>
@@ -7588,6 +9132,7 @@
           <a:lstStyle/>
           <a:p>
             <a:pPr algn="ctr"/>
+            <a:endParaRPr/>
           </a:p>
         </p:txBody>
       </p:sp>

</xml_diff>